<commit_message>
docs(deck): tighten 101 speaker notes flagged by the voice scanner
</commit_message>
<xml_diff>
--- a/presentation/datamesh-101/Datamesh_101-r1.1.pptx
+++ b/presentation/datamesh-101/Datamesh_101-r1.1.pptx
@@ -518,7 +518,7 @@
           <a:p>
             <a:r>
               <a:rPr lang="en-US" dirty="0"/>
-              <a:t>Welcome. This talk teaches the data-mesh principles from first principles and uses Quarkus to demonstrate them. No prior Quarkus experience is needed. The destination is a data mesh running on Kubernetes, and the principles we cover apply regardless of runtime. We'll start with the landscape of data architectures that came before the mesh, define the mesh through its four principles, then show why Quarkus and Kubernetes are a natural pairing for building one. By the end you should be able to explain what a data mesh is, when it's the right answer, and where to go deeper if you want to see one actually running.</a:t>
+              <a:t>Welcome. This talk teaches the data-mesh principles from first principles and uses Quarkus to demonstrate them. No prior Quarkus experience is needed. The destination is a data mesh running on Kubernetes, and the principles we cover apply regardless of runtime. We'll start with the landscape of data architectures that came before the mesh, define the mesh through its four principles, then show why Quarkus and Kubernetes are a natural pairing for building one. By the end you should be able to explain what a data mesh is, when it's the right answer, and where to go deeper to see one running.</a:t>
             </a:r>
             <a:endParaRPr lang="en-US" dirty="0"/>
           </a:p>
@@ -606,7 +606,7 @@
           <a:p>
             <a:r>
               <a:rPr lang="en-US" dirty="0"/>
-              <a:t>Domain ownership: data is owned end to end by the domain team that produces it — no central team 'owns the warehouse.' Data as a product: a data product is held to the same bar as any software product — discoverable, addressable, trustworthy, self-describing — not a renamed table. Self-serve data platform: domain teams shouldn't each build their own event streaming, observability, or registry; the platform provides that as shared infrastructure. Federated computational governance: standards are enforced computationally, by the platform, automatically — not by review meetings. All four together are what make a mesh a mesh rather than just a lot of disconnected microservices each hoarding their own data.</a:t>
+              <a:t>Domain ownership: data is owned end to end by the domain team that produces it; no central team 'owns the warehouse.' Data as a product: a data product is held to the same bar as any software product: discoverable, addressable, trustworthy, self-describing. It is not a renamed table. Self-serve data platform: domain teams shouldn't each build their own event streaming, observability, or registry; the platform provides that as shared infrastructure. Federated computational governance: standards are enforced computationally, by the platform, automatically — not by review meetings. All four together are what make a mesh a mesh rather than just a lot of disconnected microservices each hoarding their own data.</a:t>
             </a:r>
             <a:endParaRPr lang="en-US" dirty="0"/>
           </a:p>
@@ -694,7 +694,7 @@
           <a:p>
             <a:r>
               <a:rPr lang="en-US" dirty="0"/>
-              <a:t>The analogy for anyone who has been through a monolith-to-microservices transition. Just as a monolithic application gets refactored into bounded contexts owned by domain teams — the microservices transition many engineers have already lived through — a monolithic data platform gets refactored into bounded data products owned by those same domain teams. The mesh is the network of those products plus the platform and standards that let them interoperate. The hard part was never drawing the boxes; it was deciding where one bounded context ends and the next begins, and then living with the contract at that boundary. Decomposing a data platform into data products is the identical exercise, one layer up — the boundary is now a versioned data contract instead of a REST endpoint.</a:t>
+              <a:t>The analogy for anyone who has been through a monolith-to-microservices transition. Just as a monolithic application gets refactored into bounded contexts owned by domain teams (the microservices transition many engineers have already lived through), a monolithic data platform gets refactored into bounded data products owned by those same domain teams. The mesh is the network of those products plus the platform and standards that let them interoperate. The hard part was never drawing the boxes; it was deciding where one bounded context ends and the next begins, and then living with the contract at that boundary. Decomposing a data platform into data products is the identical exercise, one layer up — the boundary is now a versioned data contract instead of a REST endpoint.</a:t>
             </a:r>
             <a:endParaRPr lang="en-US" dirty="0"/>
           </a:p>
@@ -782,7 +782,7 @@
           <a:p>
             <a:r>
               <a:rPr lang="en-US" dirty="0"/>
-              <a:t>Now let's bring this back to the room. Why build a data mesh on Quarkus and Kubernetes specifically? Because Quarkus gives a single, coherent developer experience across every protocol a domain service needs — REST, gRPC, GraphQL, Kafka — without ten disconnected quickstarts, and Kubernetes's primitives map onto the four principles unusually cleanly: namespaces for domain ownership, Deployments and CRDs for data as a product, operators for the self-serve platform, and mesh/admission policy for federated governance. This section is a fast teaser — the depth lives in the 201.</a:t>
+              <a:t>Now let's bring this back to the room. Why build a data mesh on Quarkus and Kubernetes specifically? Because Quarkus gives a single, coherent developer experience across every protocol a domain service needs (REST, gRPC, GraphQL, Kafka) without ten disconnected quickstarts, and Kubernetes's primitives map onto the four principles unusually cleanly: namespaces for domain ownership, Deployments and CRDs for data as a product, operators for the self-serve platform, and mesh/admission policy for federated governance. This section is a fast teaser — the depth lives in the 201.</a:t>
             </a:r>
             <a:endParaRPr lang="en-US" dirty="0"/>
           </a:p>
@@ -1134,7 +1134,7 @@
           <a:p>
             <a:r>
               <a:rPr lang="en-US" dirty="0"/>
-              <a:t>Not every organization needs a mesh, and telling people when not to use one builds more credibility than pitching it unconditionally. The question to ask is whether the bottleneck is technical — better tools solve it — or organizational — who owns what. Pipelines still fit when the plumbing is simple. A warehouse still fits when the real need is a single governed source of truth and a central team can keep up. A lake still fits when the problem is format flexibility, not ownership. The mesh fits specifically when the organization has outgrown centralized ownership — many domains, many consumers, a central team as the constraint — and has the organizational maturity to operate domain teams that treat data as a product and a platform team that can run self-serve infrastructure. Pick the pattern that matches your actual bottleneck.</a:t>
+              <a:t>Not every organization needs a mesh, and telling people when not to use one builds more credibility than pitching it unconditionally. The question to ask is whether the bottleneck is technical (better tools solve it) or organizational (who owns what). Pipelines still fit when the plumbing is simple. A warehouse still fits when the real need is a single governed source of truth and a central team can keep up. A lake still fits when the problem is format flexibility, not ownership. The mesh fits specifically when the organization has outgrown centralized ownership (many domains, many consumers, a central team as the constraint) and has the organizational maturity to operate domain teams that treat data as a product and a platform team that can run self-serve infrastructure. Pick the pattern that matches your actual bottleneck.</a:t>
             </a:r>
             <a:endParaRPr lang="en-US" dirty="0"/>
           </a:p>
@@ -1222,7 +1222,7 @@
           <a:p>
             <a:r>
               <a:rPr lang="en-US" dirty="0"/>
-              <a:t>That's the 101: the landscape that led to data mesh, the four principles that define it, and why Quarkus and Kubernetes are a natural pairing for building one. The 201 goes deep on everything we only teased here — the full choreography-versus-orchestration comparison across Kafka, Camel, and Quarkus Flow; the Quarkus-vs-Spring-Boot side-by-side on startup time, memory, and native builds; contracts and the schema catalog; progressive delivery with mutual TLS; elastic autoscaling with KEDA; and the observability stack tying it all together. The reference repository is patterncatalyst/datamesh-reference-arch-quarkus — it's unpublished pending approval, but that's the name to look for. Thanks — happy to take questions.</a:t>
+              <a:t>That's the 101: the landscape that led to data mesh, the four principles that define it, and why Quarkus and Kubernetes are a natural pairing for building one. The 201 goes deep on everything we only teased here: the full choreography-versus-orchestration comparison across Kafka, Camel, and Quarkus Flow; the Quarkus-vs-Spring-Boot side-by-side on startup time and memory, with the JDK 25 AOT cache and native builds; contracts and the schema catalog; progressive delivery with mutual TLS; elastic autoscaling with KEDA; and the observability stack tying it all together. The reference repository is patterncatalyst/datamesh-reference-arch-quarkus. It is unpublished pending approval, but that's the name to look for. Thanks; happy to take questions.</a:t>
             </a:r>
             <a:endParaRPr lang="en-US" dirty="0"/>
           </a:p>
@@ -1574,7 +1574,7 @@
           <a:p>
             <a:r>
               <a:rPr lang="en-US" dirty="0"/>
-              <a:t>The lake solved the warehouse's format rigidity — it accepts structured, semi-structured, unstructured, and streaming data, and defers schema decisions to the point of consumption, schema-on-read instead of schema-on-write. Zone-based organization — raw, curated, refined — is how well-run lakes stay usable. But without active curation, the lake becomes a data swamp: undocumented, stale, duplicated datasets nobody trusts. And notice what didn't change — a central team still owns the bucket. The lake fixed the format problem, not the organizational one.</a:t>
+              <a:t>The lake solved the warehouse's format rigidity — it accepts structured, semi-structured, unstructured, and streaming data, and defers schema decisions to the point of consumption, schema-on-read instead of schema-on-write. Zone-based organization (raw, curated, refined) is how well-run lakes stay usable. But without active curation, the lake becomes a data swamp: undocumented, stale, duplicated datasets nobody trusts. And notice what didn't change — a central team still owns the bucket. The lake fixed the format problem, not the organizational one.</a:t>
             </a:r>
             <a:endParaRPr lang="en-US" dirty="0"/>
           </a:p>
@@ -1750,7 +1750,7 @@
           <a:p>
             <a:r>
               <a:rPr lang="en-US" dirty="0"/>
-              <a:t>This is the pivot. All three prior patterns — pipelines, warehouses, lakes — centralize data and hand ownership to a single team; the technology improves generation by generation but the organizational shape stays the same. The mesh changes the axis: instead of building a better center, decentralize ownership to the domains that produce the data. Each domain owns its data as a product — discoverable, addressable, trustworthy, self-describing — talking to other domains directly. A shared self-serve platform provides the infrastructure underneath, and federated computational governance keeps the independently-owned products interoperable. Notice there's no 'central data team' card on this diagram at all — that's the point.</a:t>
+              <a:t>This is the pivot. All three prior patterns (pipelines, warehouses, lakes) centralize data and hand ownership to a single team; the technology improves generation by generation but the organizational shape stays the same. The mesh changes the axis: instead of building a better center, decentralize ownership to the domains that produce the data. Each domain owns its data as a product that is discoverable, addressable, trustworthy, and self-describing, and talks to other domains directly. A shared self-serve platform provides the infrastructure underneath, and federated computational governance keeps the independently-owned products interoperable. Notice there's no 'central data team' card on this diagram at all — that's the point.</a:t>
             </a:r>
             <a:endParaRPr lang="en-US" dirty="0"/>
           </a:p>
@@ -1838,7 +1838,7 @@
           <a:p>
             <a:r>
               <a:rPr lang="en-US" dirty="0"/>
-              <a:t>The synthesis slide. Pipelines solved the movement problem but left sprawl and no ownership model. Warehouses solved the truth problem but left a central-team bottleneck. Lakes solved the flexibility problem but left swamp risk and the same organizational bottleneck. The mesh solves the organizational scaling problem directly — decentralized ownership — but it requires organizational maturity to pull off. This isn't 'each is strictly better than the last' — it's 'each solves a different problem.' A pipeline is still the right answer when movement is the problem. The mesh is the right answer when the bottleneck is organizational.</a:t>
+              <a:t>The synthesis slide. Pipelines solved the movement problem but left sprawl and no ownership model. Warehouses solved the truth problem but left a central-team bottleneck. Lakes solved the flexibility problem but left swamp risk and the same organizational bottleneck. The mesh solves the organizational scaling problem directly through decentralized ownership, but it requires organizational maturity to pull off. Each pattern solves a different problem; none is strictly better than the last. A pipeline is still the right answer when movement is the problem. The mesh is the right answer when the bottleneck is organizational.</a:t>
             </a:r>
             <a:endParaRPr lang="en-US" dirty="0"/>
           </a:p>

</xml_diff>

<commit_message>
docs(deck): tighten 101 speaker notes flagged by the voice scanner (#32)
</commit_message>
<xml_diff>
--- a/presentation/datamesh-101/Datamesh_101-r1.1.pptx
+++ b/presentation/datamesh-101/Datamesh_101-r1.1.pptx
@@ -518,7 +518,7 @@
           <a:p>
             <a:r>
               <a:rPr lang="en-US" dirty="0"/>
-              <a:t>Welcome. This talk teaches the data-mesh principles from first principles and uses Quarkus to demonstrate them. No prior Quarkus experience is needed. The destination is a data mesh running on Kubernetes, and the principles we cover apply regardless of runtime. We'll start with the landscape of data architectures that came before the mesh, define the mesh through its four principles, then show why Quarkus and Kubernetes are a natural pairing for building one. By the end you should be able to explain what a data mesh is, when it's the right answer, and where to go deeper if you want to see one actually running.</a:t>
+              <a:t>Welcome. This talk teaches the data-mesh principles from first principles and uses Quarkus to demonstrate them. No prior Quarkus experience is needed. The destination is a data mesh running on Kubernetes, and the principles we cover apply regardless of runtime. We'll start with the landscape of data architectures that came before the mesh, define the mesh through its four principles, then show why Quarkus and Kubernetes are a natural pairing for building one. By the end you should be able to explain what a data mesh is, when it's the right answer, and where to go deeper to see one running.</a:t>
             </a:r>
             <a:endParaRPr lang="en-US" dirty="0"/>
           </a:p>
@@ -606,7 +606,7 @@
           <a:p>
             <a:r>
               <a:rPr lang="en-US" dirty="0"/>
-              <a:t>Domain ownership: data is owned end to end by the domain team that produces it — no central team 'owns the warehouse.' Data as a product: a data product is held to the same bar as any software product — discoverable, addressable, trustworthy, self-describing — not a renamed table. Self-serve data platform: domain teams shouldn't each build their own event streaming, observability, or registry; the platform provides that as shared infrastructure. Federated computational governance: standards are enforced computationally, by the platform, automatically — not by review meetings. All four together are what make a mesh a mesh rather than just a lot of disconnected microservices each hoarding their own data.</a:t>
+              <a:t>Domain ownership: data is owned end to end by the domain team that produces it; no central team 'owns the warehouse.' Data as a product: a data product is held to the same bar as any software product: discoverable, addressable, trustworthy, self-describing. It is not a renamed table. Self-serve data platform: domain teams shouldn't each build their own event streaming, observability, or registry; the platform provides that as shared infrastructure. Federated computational governance: standards are enforced computationally, by the platform, automatically — not by review meetings. All four together are what make a mesh a mesh rather than just a lot of disconnected microservices each hoarding their own data.</a:t>
             </a:r>
             <a:endParaRPr lang="en-US" dirty="0"/>
           </a:p>
@@ -694,7 +694,7 @@
           <a:p>
             <a:r>
               <a:rPr lang="en-US" dirty="0"/>
-              <a:t>The analogy for anyone who has been through a monolith-to-microservices transition. Just as a monolithic application gets refactored into bounded contexts owned by domain teams — the microservices transition many engineers have already lived through — a monolithic data platform gets refactored into bounded data products owned by those same domain teams. The mesh is the network of those products plus the platform and standards that let them interoperate. The hard part was never drawing the boxes; it was deciding where one bounded context ends and the next begins, and then living with the contract at that boundary. Decomposing a data platform into data products is the identical exercise, one layer up — the boundary is now a versioned data contract instead of a REST endpoint.</a:t>
+              <a:t>The analogy for anyone who has been through a monolith-to-microservices transition. Just as a monolithic application gets refactored into bounded contexts owned by domain teams (the microservices transition many engineers have already lived through), a monolithic data platform gets refactored into bounded data products owned by those same domain teams. The mesh is the network of those products plus the platform and standards that let them interoperate. The hard part was never drawing the boxes; it was deciding where one bounded context ends and the next begins, and then living with the contract at that boundary. Decomposing a data platform into data products is the identical exercise, one layer up — the boundary is now a versioned data contract instead of a REST endpoint.</a:t>
             </a:r>
             <a:endParaRPr lang="en-US" dirty="0"/>
           </a:p>
@@ -782,7 +782,7 @@
           <a:p>
             <a:r>
               <a:rPr lang="en-US" dirty="0"/>
-              <a:t>Now let's bring this back to the room. Why build a data mesh on Quarkus and Kubernetes specifically? Because Quarkus gives a single, coherent developer experience across every protocol a domain service needs — REST, gRPC, GraphQL, Kafka — without ten disconnected quickstarts, and Kubernetes's primitives map onto the four principles unusually cleanly: namespaces for domain ownership, Deployments and CRDs for data as a product, operators for the self-serve platform, and mesh/admission policy for federated governance. This section is a fast teaser — the depth lives in the 201.</a:t>
+              <a:t>Now let's bring this back to the room. Why build a data mesh on Quarkus and Kubernetes specifically? Because Quarkus gives a single, coherent developer experience across every protocol a domain service needs (REST, gRPC, GraphQL, Kafka) without ten disconnected quickstarts, and Kubernetes's primitives map onto the four principles unusually cleanly: namespaces for domain ownership, Deployments and CRDs for data as a product, operators for the self-serve platform, and mesh/admission policy for federated governance. This section is a fast teaser — the depth lives in the 201.</a:t>
             </a:r>
             <a:endParaRPr lang="en-US" dirty="0"/>
           </a:p>
@@ -1134,7 +1134,7 @@
           <a:p>
             <a:r>
               <a:rPr lang="en-US" dirty="0"/>
-              <a:t>Not every organization needs a mesh, and telling people when not to use one builds more credibility than pitching it unconditionally. The question to ask is whether the bottleneck is technical — better tools solve it — or organizational — who owns what. Pipelines still fit when the plumbing is simple. A warehouse still fits when the real need is a single governed source of truth and a central team can keep up. A lake still fits when the problem is format flexibility, not ownership. The mesh fits specifically when the organization has outgrown centralized ownership — many domains, many consumers, a central team as the constraint — and has the organizational maturity to operate domain teams that treat data as a product and a platform team that can run self-serve infrastructure. Pick the pattern that matches your actual bottleneck.</a:t>
+              <a:t>Not every organization needs a mesh, and telling people when not to use one builds more credibility than pitching it unconditionally. The question to ask is whether the bottleneck is technical (better tools solve it) or organizational (who owns what). Pipelines still fit when the plumbing is simple. A warehouse still fits when the real need is a single governed source of truth and a central team can keep up. A lake still fits when the problem is format flexibility, not ownership. The mesh fits specifically when the organization has outgrown centralized ownership (many domains, many consumers, a central team as the constraint) and has the organizational maturity to operate domain teams that treat data as a product and a platform team that can run self-serve infrastructure. Pick the pattern that matches your actual bottleneck.</a:t>
             </a:r>
             <a:endParaRPr lang="en-US" dirty="0"/>
           </a:p>
@@ -1222,7 +1222,7 @@
           <a:p>
             <a:r>
               <a:rPr lang="en-US" dirty="0"/>
-              <a:t>That's the 101: the landscape that led to data mesh, the four principles that define it, and why Quarkus and Kubernetes are a natural pairing for building one. The 201 goes deep on everything we only teased here — the full choreography-versus-orchestration comparison across Kafka, Camel, and Quarkus Flow; the Quarkus-vs-Spring-Boot side-by-side on startup time, memory, and native builds; contracts and the schema catalog; progressive delivery with mutual TLS; elastic autoscaling with KEDA; and the observability stack tying it all together. The reference repository is patterncatalyst/datamesh-reference-arch-quarkus — it's unpublished pending approval, but that's the name to look for. Thanks — happy to take questions.</a:t>
+              <a:t>That's the 101: the landscape that led to data mesh, the four principles that define it, and why Quarkus and Kubernetes are a natural pairing for building one. The 201 goes deep on everything we only teased here: the full choreography-versus-orchestration comparison across Kafka, Camel, and Quarkus Flow; the Quarkus-vs-Spring-Boot side-by-side on startup time and memory, with the JDK 25 AOT cache and native builds; contracts and the schema catalog; progressive delivery with mutual TLS; elastic autoscaling with KEDA; and the observability stack tying it all together. The reference repository is patterncatalyst/datamesh-reference-arch-quarkus. It is unpublished pending approval, but that's the name to look for. Thanks; happy to take questions.</a:t>
             </a:r>
             <a:endParaRPr lang="en-US" dirty="0"/>
           </a:p>
@@ -1574,7 +1574,7 @@
           <a:p>
             <a:r>
               <a:rPr lang="en-US" dirty="0"/>
-              <a:t>The lake solved the warehouse's format rigidity — it accepts structured, semi-structured, unstructured, and streaming data, and defers schema decisions to the point of consumption, schema-on-read instead of schema-on-write. Zone-based organization — raw, curated, refined — is how well-run lakes stay usable. But without active curation, the lake becomes a data swamp: undocumented, stale, duplicated datasets nobody trusts. And notice what didn't change — a central team still owns the bucket. The lake fixed the format problem, not the organizational one.</a:t>
+              <a:t>The lake solved the warehouse's format rigidity — it accepts structured, semi-structured, unstructured, and streaming data, and defers schema decisions to the point of consumption, schema-on-read instead of schema-on-write. Zone-based organization (raw, curated, refined) is how well-run lakes stay usable. But without active curation, the lake becomes a data swamp: undocumented, stale, duplicated datasets nobody trusts. And notice what didn't change — a central team still owns the bucket. The lake fixed the format problem, not the organizational one.</a:t>
             </a:r>
             <a:endParaRPr lang="en-US" dirty="0"/>
           </a:p>
@@ -1750,7 +1750,7 @@
           <a:p>
             <a:r>
               <a:rPr lang="en-US" dirty="0"/>
-              <a:t>This is the pivot. All three prior patterns — pipelines, warehouses, lakes — centralize data and hand ownership to a single team; the technology improves generation by generation but the organizational shape stays the same. The mesh changes the axis: instead of building a better center, decentralize ownership to the domains that produce the data. Each domain owns its data as a product — discoverable, addressable, trustworthy, self-describing — talking to other domains directly. A shared self-serve platform provides the infrastructure underneath, and federated computational governance keeps the independently-owned products interoperable. Notice there's no 'central data team' card on this diagram at all — that's the point.</a:t>
+              <a:t>This is the pivot. All three prior patterns (pipelines, warehouses, lakes) centralize data and hand ownership to a single team; the technology improves generation by generation but the organizational shape stays the same. The mesh changes the axis: instead of building a better center, decentralize ownership to the domains that produce the data. Each domain owns its data as a product that is discoverable, addressable, trustworthy, and self-describing, and talks to other domains directly. A shared self-serve platform provides the infrastructure underneath, and federated computational governance keeps the independently-owned products interoperable. Notice there's no 'central data team' card on this diagram at all — that's the point.</a:t>
             </a:r>
             <a:endParaRPr lang="en-US" dirty="0"/>
           </a:p>
@@ -1838,7 +1838,7 @@
           <a:p>
             <a:r>
               <a:rPr lang="en-US" dirty="0"/>
-              <a:t>The synthesis slide. Pipelines solved the movement problem but left sprawl and no ownership model. Warehouses solved the truth problem but left a central-team bottleneck. Lakes solved the flexibility problem but left swamp risk and the same organizational bottleneck. The mesh solves the organizational scaling problem directly — decentralized ownership — but it requires organizational maturity to pull off. This isn't 'each is strictly better than the last' — it's 'each solves a different problem.' A pipeline is still the right answer when movement is the problem. The mesh is the right answer when the bottleneck is organizational.</a:t>
+              <a:t>The synthesis slide. Pipelines solved the movement problem but left sprawl and no ownership model. Warehouses solved the truth problem but left a central-team bottleneck. Lakes solved the flexibility problem but left swamp risk and the same organizational bottleneck. The mesh solves the organizational scaling problem directly through decentralized ownership, but it requires organizational maturity to pull off. Each pattern solves a different problem; none is strictly better than the last. A pipeline is still the right answer when movement is the problem. The mesh is the right answer when the bottleneck is organizational.</a:t>
             </a:r>
             <a:endParaRPr lang="en-US" dirty="0"/>
           </a:p>

</xml_diff>

<commit_message>
feat(deck): add closing 'Scan to explore' QR slide to the 101 and 201 decks
New final slide (after the closing divider) on both the Datamesh 101 and the
Datamesh 201 (Quarkus) decks, matching the API REST decks: two QR codes — left to
the reference-architecture site, right to the Workshops & Tutorials hub. Adds
segno-generated qr-site.png / qr-hub.png to each deck dir and rebuilds both .pptx.

Note: dpng/ is a gitignored build artifact; regenerated from assets/diagrams via
raster.js (sharp) before the 201 rebuild.

🤖 Generated with [Claude Code](https://claude.com/claude-code)

Co-Authored-By: Claude <noreply@anthropic.com>
</commit_message>
<xml_diff>
--- a/presentation/datamesh-101/Datamesh_101-r1.1.pptx
+++ b/presentation/datamesh-101/Datamesh_101-r1.1.pptx
@@ -22,9 +22,10 @@
     <p:sldId id="270" r:id="rId16"/>
     <p:sldId id="271" r:id="rId17"/>
     <p:sldId id="272" r:id="rId18"/>
+    <p:sldId id="273" r:id="rId19"/>
   </p:sldIdLst>
   <p:notesMasterIdLst>
-    <p:notesMasterId r:id="rId19"/>
+    <p:notesMasterId r:id="rId20"/>
   </p:notesMasterIdLst>
   <p:sldSz cx="12191695" cy="6858000"/>
   <p:notesSz cx="6858000" cy="12191695"/>
@@ -1246,6 +1247,94 @@
             <a:fld id="{F7021451-1387-4CA6-816F-3879F97B5CBC}" type="slidenum">
               <a:rPr lang="en-US"/>
               <a:t>17</a:t>
+            </a:fld>
+            <a:endParaRPr lang="en-US"/>
+          </a:p>
+        </p:txBody>
+      </p:sp>
+    </p:spTree>
+    <p:extLst>
+      <p:ext uri="{BB962C8B-B14F-4D97-AF65-F5344CB8AC3E}">
+        <p14:creationId xmlns:p14="http://schemas.microsoft.com/office/powerpoint/2010/main" val="1024086991"/>
+      </p:ext>
+    </p:extLst>
+  </p:cSld>
+  <p:clrMapOvr>
+    <a:masterClrMapping/>
+  </p:clrMapOvr>
+</p:notes>
+</file>
+
+<file path=ppt/notesSlides/notesSlide18.xml><?xml version="1.0" encoding="utf-8"?>
+<p:notes xmlns:a="http://schemas.openxmlformats.org/drawingml/2006/main" xmlns:r="http://schemas.openxmlformats.org/officeDocument/2006/relationships" xmlns:p="http://schemas.openxmlformats.org/presentationml/2006/main">
+  <p:cSld>
+    <p:spTree>
+      <p:nvGrpSpPr>
+        <p:cNvPr id="1" name=""/>
+        <p:cNvGrpSpPr/>
+        <p:nvPr/>
+      </p:nvGrpSpPr>
+      <p:grpSpPr>
+        <a:xfrm>
+          <a:off x="0" y="0"/>
+          <a:ext cx="0" cy="0"/>
+          <a:chOff x="0" y="0"/>
+          <a:chExt cx="0" cy="0"/>
+        </a:xfrm>
+      </p:grpSpPr>
+      <p:sp>
+        <p:nvSpPr>
+          <p:cNvPr id="2" name="Slide Image Placeholder 1"/>
+          <p:cNvSpPr>
+            <a:spLocks noGrp="1" noRot="1" noChangeAspect="1"/>
+          </p:cNvSpPr>
+          <p:nvPr>
+            <p:ph type="sldImg"/>
+          </p:nvPr>
+        </p:nvSpPr>
+        <p:spPr/>
+      </p:sp>
+      <p:sp>
+        <p:nvSpPr>
+          <p:cNvPr id="3" name="Notes Placeholder 2"/>
+          <p:cNvSpPr>
+            <a:spLocks noGrp="1"/>
+          </p:cNvSpPr>
+          <p:nvPr>
+            <p:ph type="body" idx="1"/>
+          </p:nvPr>
+        </p:nvSpPr>
+        <p:spPr/>
+        <p:txBody>
+          <a:bodyPr/>
+          <a:lstStyle/>
+          <a:p>
+            <a:r>
+              <a:rPr lang="en-US" dirty="0"/>
+              <a:t>That's where to go next. The two codes carry the talk home: on the left, the reference architecture itself — the site, the runnable Quarkus domain services, the contracts and schema catalog, and the single-command minikube bootstrap that stands the whole mesh up on a laptop. On the right, the Workshops and Tutorials hub: every workshop, tutorial, and deck in the series in one place, including the 201 deep-dive. Scan whichever is useful; both are public on the Pattern Catalyst GitHub organization.</a:t>
+            </a:r>
+            <a:endParaRPr lang="en-US" dirty="0"/>
+          </a:p>
+        </p:txBody>
+      </p:sp>
+      <p:sp>
+        <p:nvSpPr>
+          <p:cNvPr id="4" name="Slide Number Placeholder 3"/>
+          <p:cNvSpPr>
+            <a:spLocks noGrp="1"/>
+          </p:cNvSpPr>
+          <p:nvPr>
+            <p:ph type="sldNum" sz="quarter" idx="10"/>
+          </p:nvPr>
+        </p:nvSpPr>
+        <p:spPr/>
+        <p:txBody>
+          <a:bodyPr/>
+          <a:lstStyle/>
+          <a:p>
+            <a:fld id="{F7021451-1387-4CA6-816F-3879F97B5CBC}" type="slidenum">
+              <a:rPr lang="en-US"/>
+              <a:t>18</a:t>
             </a:fld>
             <a:endParaRPr lang="en-US"/>
           </a:p>
@@ -3295,8 +3384,8 @@
         </p:blipFill>
         <p:spPr>
           <a:xfrm>
-            <a:off x="1221100" y="1645920"/>
-            <a:ext cx="9749496" cy="3931920"/>
+            <a:off x="2413324" y="1645920"/>
+            <a:ext cx="7365048" cy="3931920"/>
           </a:xfrm>
           <a:prstGeom prst="rect">
             <a:avLst/>
@@ -4464,6 +4553,461 @@
           </a:prstGeom>
         </p:spPr>
       </p:pic>
+    </p:spTree>
+  </p:cSld>
+  <p:clrMapOvr>
+    <a:masterClrMapping/>
+  </p:clrMapOvr>
+</p:sld>
+</file>
+
+<file path=ppt/slides/slide18.xml><?xml version="1.0" encoding="utf-8"?>
+<p:sld xmlns:a="http://schemas.openxmlformats.org/drawingml/2006/main" xmlns:r="http://schemas.openxmlformats.org/officeDocument/2006/relationships" xmlns:p="http://schemas.openxmlformats.org/presentationml/2006/main">
+  <p:cSld name="Slide 18">
+    <p:bg>
+      <p:bgPr>
+        <a:solidFill>
+          <a:srgbClr val="FFFFFF"/>
+        </a:solidFill>
+      </p:bgPr>
+    </p:bg>
+    <p:spTree>
+      <p:nvGrpSpPr>
+        <p:cNvPr id="1" name=""/>
+        <p:cNvGrpSpPr/>
+        <p:nvPr/>
+      </p:nvGrpSpPr>
+      <p:grpSpPr>
+        <a:xfrm>
+          <a:off x="0" y="0"/>
+          <a:ext cx="0" cy="0"/>
+          <a:chOff x="0" y="0"/>
+          <a:chExt cx="0" cy="0"/>
+        </a:xfrm>
+      </p:grpSpPr>
+      <p:sp>
+        <p:nvSpPr>
+          <p:cNvPr id="2" name="Text 0"/>
+          <p:cNvSpPr/>
+          <p:nvPr/>
+        </p:nvSpPr>
+        <p:spPr>
+          <a:xfrm>
+            <a:off x="457200" y="6400800"/>
+            <a:ext cx="914400" cy="274320"/>
+          </a:xfrm>
+          <a:prstGeom prst="rect">
+            <a:avLst/>
+          </a:prstGeom>
+          <a:noFill/>
+          <a:ln/>
+        </p:spPr>
+        <p:txBody>
+          <a:bodyPr wrap="square" lIns="0" tIns="0" rIns="0" bIns="0" rtlCol="0" anchor="ctr"/>
+          <a:lstStyle/>
+          <a:p>
+            <a:pPr algn="l" indent="0" marL="0">
+              <a:buNone/>
+            </a:pPr>
+            <a:r>
+              <a:rPr lang="en-US" sz="1000" dirty="0">
+                <a:solidFill>
+                  <a:srgbClr val="8A8A8A"/>
+                </a:solidFill>
+                <a:latin typeface="Red Hat Text" pitchFamily="34" charset="0"/>
+                <a:ea typeface="Red Hat Text" pitchFamily="34" charset="-122"/>
+                <a:cs typeface="Red Hat Text" pitchFamily="34" charset="-120"/>
+              </a:rPr>
+              <a:t>17</a:t>
+            </a:r>
+            <a:endParaRPr lang="en-US" sz="1000" dirty="0"/>
+          </a:p>
+        </p:txBody>
+      </p:sp>
+      <p:pic>
+        <p:nvPicPr>
+          <p:cNvPr id="3" name="Image 0" descr="brand-logo-dark.png">    </p:cNvPr>
+          <p:cNvPicPr>
+            <a:picLocks noChangeAspect="1"/>
+          </p:cNvPicPr>
+          <p:nvPr/>
+        </p:nvPicPr>
+        <p:blipFill>
+          <a:blip r:embed="rId1"/>
+          <a:stretch>
+            <a:fillRect/>
+          </a:stretch>
+        </p:blipFill>
+        <p:spPr>
+          <a:xfrm>
+            <a:off x="10591495" y="6353919"/>
+            <a:ext cx="1051560" cy="248049"/>
+          </a:xfrm>
+          <a:prstGeom prst="rect">
+            <a:avLst/>
+          </a:prstGeom>
+        </p:spPr>
+      </p:pic>
+      <p:sp>
+        <p:nvSpPr>
+          <p:cNvPr id="4" name="Text 1"/>
+          <p:cNvSpPr/>
+          <p:nvPr/>
+        </p:nvSpPr>
+        <p:spPr>
+          <a:xfrm>
+            <a:off x="640080" y="411480"/>
+            <a:ext cx="10911535" cy="292608"/>
+          </a:xfrm>
+          <a:prstGeom prst="rect">
+            <a:avLst/>
+          </a:prstGeom>
+          <a:noFill/>
+          <a:ln/>
+        </p:spPr>
+        <p:txBody>
+          <a:bodyPr wrap="square" lIns="0" tIns="0" rIns="0" bIns="0" rtlCol="0" anchor="ctr"/>
+          <a:lstStyle/>
+          <a:p>
+            <a:pPr indent="0" marL="0">
+              <a:buNone/>
+            </a:pPr>
+            <a:r>
+              <a:rPr lang="en-US" sz="1200" b="1" spc="200" kern="0" dirty="0">
+                <a:solidFill>
+                  <a:srgbClr val="EE0000"/>
+                </a:solidFill>
+                <a:latin typeface="Overpass SemiBold" pitchFamily="34" charset="0"/>
+                <a:ea typeface="Overpass SemiBold" pitchFamily="34" charset="-122"/>
+                <a:cs typeface="Overpass SemiBold" pitchFamily="34" charset="-120"/>
+              </a:rPr>
+              <a:t>SCAN TO EXPLORE</a:t>
+            </a:r>
+            <a:endParaRPr lang="en-US" sz="1200" dirty="0"/>
+          </a:p>
+        </p:txBody>
+      </p:sp>
+      <p:sp>
+        <p:nvSpPr>
+          <p:cNvPr id="5" name="Text 2"/>
+          <p:cNvSpPr/>
+          <p:nvPr/>
+        </p:nvSpPr>
+        <p:spPr>
+          <a:xfrm>
+            <a:off x="640080" y="713232"/>
+            <a:ext cx="10911535" cy="868680"/>
+          </a:xfrm>
+          <a:prstGeom prst="rect">
+            <a:avLst/>
+          </a:prstGeom>
+          <a:noFill/>
+          <a:ln/>
+        </p:spPr>
+        <p:txBody>
+          <a:bodyPr wrap="square" lIns="0" tIns="0" rIns="0" bIns="0" rtlCol="0" anchor="t"/>
+          <a:lstStyle/>
+          <a:p>
+            <a:pPr indent="0" marL="0">
+              <a:buNone/>
+            </a:pPr>
+            <a:r>
+              <a:rPr lang="en-US" sz="3000" b="1" dirty="0">
+                <a:solidFill>
+                  <a:srgbClr val="151515"/>
+                </a:solidFill>
+                <a:latin typeface="Overpass SemiBold" pitchFamily="34" charset="0"/>
+                <a:ea typeface="Overpass SemiBold" pitchFamily="34" charset="-122"/>
+                <a:cs typeface="Overpass SemiBold" pitchFamily="34" charset="-120"/>
+              </a:rPr>
+              <a:t>Take it with you</a:t>
+            </a:r>
+            <a:endParaRPr lang="en-US" sz="3000" dirty="0"/>
+          </a:p>
+        </p:txBody>
+      </p:sp>
+      <p:pic>
+        <p:nvPicPr>
+          <p:cNvPr id="6" name="Image 1" descr="qr-site.png">    </p:cNvPr>
+          <p:cNvPicPr>
+            <a:picLocks noChangeAspect="1"/>
+          </p:cNvPicPr>
+          <p:nvPr/>
+        </p:nvPicPr>
+        <p:blipFill>
+          <a:blip r:embed="rId2"/>
+          <a:stretch>
+            <a:fillRect/>
+          </a:stretch>
+        </p:blipFill>
+        <p:spPr>
+          <a:xfrm>
+            <a:off x="2103120" y="1783080"/>
+            <a:ext cx="2834640" cy="2834640"/>
+          </a:xfrm>
+          <a:prstGeom prst="rect">
+            <a:avLst/>
+          </a:prstGeom>
+        </p:spPr>
+      </p:pic>
+      <p:sp>
+        <p:nvSpPr>
+          <p:cNvPr id="7" name="Text 3"/>
+          <p:cNvSpPr/>
+          <p:nvPr/>
+        </p:nvSpPr>
+        <p:spPr>
+          <a:xfrm>
+            <a:off x="1417320" y="4754880"/>
+            <a:ext cx="4206240" cy="365760"/>
+          </a:xfrm>
+          <a:prstGeom prst="rect">
+            <a:avLst/>
+          </a:prstGeom>
+          <a:noFill/>
+          <a:ln/>
+        </p:spPr>
+        <p:txBody>
+          <a:bodyPr wrap="square" lIns="0" tIns="0" rIns="0" bIns="0" rtlCol="0" anchor="ctr"/>
+          <a:lstStyle/>
+          <a:p>
+            <a:pPr algn="ctr" indent="0" marL="0">
+              <a:buNone/>
+            </a:pPr>
+            <a:r>
+              <a:rPr lang="en-US" sz="1800" b="1" dirty="0">
+                <a:solidFill>
+                  <a:srgbClr val="151515"/>
+                </a:solidFill>
+                <a:latin typeface="Overpass SemiBold" pitchFamily="34" charset="0"/>
+                <a:ea typeface="Overpass SemiBold" pitchFamily="34" charset="-122"/>
+                <a:cs typeface="Overpass SemiBold" pitchFamily="34" charset="-120"/>
+              </a:rPr>
+              <a:t>The reference architecture</a:t>
+            </a:r>
+            <a:endParaRPr lang="en-US" sz="1800" dirty="0"/>
+          </a:p>
+        </p:txBody>
+      </p:sp>
+      <p:sp>
+        <p:nvSpPr>
+          <p:cNvPr id="8" name="Text 4"/>
+          <p:cNvSpPr/>
+          <p:nvPr/>
+        </p:nvSpPr>
+        <p:spPr>
+          <a:xfrm>
+            <a:off x="1325880" y="5138928"/>
+            <a:ext cx="4389120" cy="640080"/>
+          </a:xfrm>
+          <a:prstGeom prst="rect">
+            <a:avLst/>
+          </a:prstGeom>
+          <a:noFill/>
+          <a:ln/>
+        </p:spPr>
+        <p:txBody>
+          <a:bodyPr wrap="square" lIns="0" tIns="0" rIns="0" bIns="0" rtlCol="0" anchor="t"/>
+          <a:lstStyle/>
+          <a:p>
+            <a:pPr algn="ctr" indent="0" marL="0">
+              <a:buNone/>
+            </a:pPr>
+            <a:r>
+              <a:rPr lang="en-US" sz="1300" i="1" dirty="0">
+                <a:solidFill>
+                  <a:srgbClr val="5A5A5A"/>
+                </a:solidFill>
+                <a:latin typeface="Red Hat Text" pitchFamily="34" charset="0"/>
+                <a:ea typeface="Red Hat Text" pitchFamily="34" charset="-122"/>
+                <a:cs typeface="Red Hat Text" pitchFamily="34" charset="-120"/>
+              </a:rPr>
+              <a:t>Site, runnable Quarkus services, contracts, and the minikube bootstrap</a:t>
+            </a:r>
+            <a:endParaRPr lang="en-US" sz="1300" dirty="0"/>
+          </a:p>
+        </p:txBody>
+      </p:sp>
+      <p:sp>
+        <p:nvSpPr>
+          <p:cNvPr id="9" name="Text 5"/>
+          <p:cNvSpPr/>
+          <p:nvPr/>
+        </p:nvSpPr>
+        <p:spPr>
+          <a:xfrm>
+            <a:off x="1325880" y="5760720"/>
+            <a:ext cx="4389120" cy="292608"/>
+          </a:xfrm>
+          <a:prstGeom prst="rect">
+            <a:avLst/>
+          </a:prstGeom>
+          <a:noFill/>
+          <a:ln/>
+        </p:spPr>
+        <p:txBody>
+          <a:bodyPr wrap="square" lIns="0" tIns="0" rIns="0" bIns="0" rtlCol="0" anchor="ctr"/>
+          <a:lstStyle/>
+          <a:p>
+            <a:pPr algn="ctr" indent="0" marL="0">
+              <a:buNone/>
+            </a:pPr>
+            <a:r>
+              <a:rPr lang="en-US" sz="1000" dirty="0">
+                <a:solidFill>
+                  <a:srgbClr val="EE0000"/>
+                </a:solidFill>
+                <a:latin typeface="Red Hat Mono" pitchFamily="34" charset="0"/>
+                <a:ea typeface="Red Hat Mono" pitchFamily="34" charset="-122"/>
+                <a:cs typeface="Red Hat Mono" pitchFamily="34" charset="-120"/>
+              </a:rPr>
+              <a:t>patterncatalyst.github.io/datamesh-reference-arch-quarkus</a:t>
+            </a:r>
+            <a:endParaRPr lang="en-US" sz="1000" dirty="0"/>
+          </a:p>
+        </p:txBody>
+      </p:sp>
+      <p:pic>
+        <p:nvPicPr>
+          <p:cNvPr id="10" name="Image 2" descr="qr-hub.png">    </p:cNvPr>
+          <p:cNvPicPr>
+            <a:picLocks noChangeAspect="1"/>
+          </p:cNvPicPr>
+          <p:nvPr/>
+        </p:nvPicPr>
+        <p:blipFill>
+          <a:blip r:embed="rId3"/>
+          <a:stretch>
+            <a:fillRect/>
+          </a:stretch>
+        </p:blipFill>
+        <p:spPr>
+          <a:xfrm>
+            <a:off x="7251192" y="1783080"/>
+            <a:ext cx="2834640" cy="2834640"/>
+          </a:xfrm>
+          <a:prstGeom prst="rect">
+            <a:avLst/>
+          </a:prstGeom>
+        </p:spPr>
+      </p:pic>
+      <p:sp>
+        <p:nvSpPr>
+          <p:cNvPr id="11" name="Text 6"/>
+          <p:cNvSpPr/>
+          <p:nvPr/>
+        </p:nvSpPr>
+        <p:spPr>
+          <a:xfrm>
+            <a:off x="6565392" y="4754880"/>
+            <a:ext cx="4206240" cy="365760"/>
+          </a:xfrm>
+          <a:prstGeom prst="rect">
+            <a:avLst/>
+          </a:prstGeom>
+          <a:noFill/>
+          <a:ln/>
+        </p:spPr>
+        <p:txBody>
+          <a:bodyPr wrap="square" lIns="0" tIns="0" rIns="0" bIns="0" rtlCol="0" anchor="ctr"/>
+          <a:lstStyle/>
+          <a:p>
+            <a:pPr algn="ctr" indent="0" marL="0">
+              <a:buNone/>
+            </a:pPr>
+            <a:r>
+              <a:rPr lang="en-US" sz="1800" b="1" dirty="0">
+                <a:solidFill>
+                  <a:srgbClr val="151515"/>
+                </a:solidFill>
+                <a:latin typeface="Overpass SemiBold" pitchFamily="34" charset="0"/>
+                <a:ea typeface="Overpass SemiBold" pitchFamily="34" charset="-122"/>
+                <a:cs typeface="Overpass SemiBold" pitchFamily="34" charset="-120"/>
+              </a:rPr>
+              <a:t>Workshops &amp; Tutorials</a:t>
+            </a:r>
+            <a:endParaRPr lang="en-US" sz="1800" dirty="0"/>
+          </a:p>
+        </p:txBody>
+      </p:sp>
+      <p:sp>
+        <p:nvSpPr>
+          <p:cNvPr id="12" name="Text 7"/>
+          <p:cNvSpPr/>
+          <p:nvPr/>
+        </p:nvSpPr>
+        <p:spPr>
+          <a:xfrm>
+            <a:off x="6473952" y="5138928"/>
+            <a:ext cx="4389120" cy="640080"/>
+          </a:xfrm>
+          <a:prstGeom prst="rect">
+            <a:avLst/>
+          </a:prstGeom>
+          <a:noFill/>
+          <a:ln/>
+        </p:spPr>
+        <p:txBody>
+          <a:bodyPr wrap="square" lIns="0" tIns="0" rIns="0" bIns="0" rtlCol="0" anchor="t"/>
+          <a:lstStyle/>
+          <a:p>
+            <a:pPr algn="ctr" indent="0" marL="0">
+              <a:buNone/>
+            </a:pPr>
+            <a:r>
+              <a:rPr lang="en-US" sz="1300" i="1" dirty="0">
+                <a:solidFill>
+                  <a:srgbClr val="5A5A5A"/>
+                </a:solidFill>
+                <a:latin typeface="Red Hat Text" pitchFamily="34" charset="0"/>
+                <a:ea typeface="Red Hat Text" pitchFamily="34" charset="-122"/>
+                <a:cs typeface="Red Hat Text" pitchFamily="34" charset="-120"/>
+              </a:rPr>
+              <a:t>The whole series — every workshop, tutorial, and deck in one place</a:t>
+            </a:r>
+            <a:endParaRPr lang="en-US" sz="1300" dirty="0"/>
+          </a:p>
+        </p:txBody>
+      </p:sp>
+      <p:sp>
+        <p:nvSpPr>
+          <p:cNvPr id="13" name="Text 8"/>
+          <p:cNvSpPr/>
+          <p:nvPr/>
+        </p:nvSpPr>
+        <p:spPr>
+          <a:xfrm>
+            <a:off x="6382512" y="5760720"/>
+            <a:ext cx="4572000" cy="292608"/>
+          </a:xfrm>
+          <a:prstGeom prst="rect">
+            <a:avLst/>
+          </a:prstGeom>
+          <a:noFill/>
+          <a:ln/>
+        </p:spPr>
+        <p:txBody>
+          <a:bodyPr wrap="square" lIns="0" tIns="0" rIns="0" bIns="0" rtlCol="0" anchor="ctr"/>
+          <a:lstStyle/>
+          <a:p>
+            <a:pPr algn="ctr" indent="0" marL="0">
+              <a:buNone/>
+            </a:pPr>
+            <a:r>
+              <a:rPr lang="en-US" sz="900" dirty="0">
+                <a:solidFill>
+                  <a:srgbClr val="EE0000"/>
+                </a:solidFill>
+                <a:latin typeface="Red Hat Mono" pitchFamily="34" charset="0"/>
+                <a:ea typeface="Red Hat Mono" pitchFamily="34" charset="-122"/>
+                <a:cs typeface="Red Hat Mono" pitchFamily="34" charset="-120"/>
+              </a:rPr>
+              <a:t>patterncatalyst.github.io/patterncatalyst-workshops-tutorials-list</a:t>
+            </a:r>
+            <a:endParaRPr lang="en-US" sz="900" dirty="0"/>
+          </a:p>
+        </p:txBody>
+      </p:sp>
     </p:spTree>
   </p:cSld>
   <p:clrMapOvr>

</xml_diff>

<commit_message>
feat(deck): add closing 'Scan to explore' QR slide to the 101 and 201 decks (#56)
New final slide (after the closing divider) on both the Datamesh 101 and the
Datamesh 201 (Quarkus) decks, matching the API REST decks: two QR codes — left to
the reference-architecture site, right to the Workshops & Tutorials hub. Adds
segno-generated qr-site.png / qr-hub.png to each deck dir and rebuilds both .pptx.

Note: dpng/ is a gitignored build artifact; regenerated from assets/diagrams via
raster.js (sharp) before the 201 rebuild.

🤖 Generated with [Claude Code](https://claude.com/claude-code)

Co-authored-by: Claude <noreply@anthropic.com>
</commit_message>
<xml_diff>
--- a/presentation/datamesh-101/Datamesh_101-r1.1.pptx
+++ b/presentation/datamesh-101/Datamesh_101-r1.1.pptx
@@ -22,9 +22,10 @@
     <p:sldId id="270" r:id="rId16"/>
     <p:sldId id="271" r:id="rId17"/>
     <p:sldId id="272" r:id="rId18"/>
+    <p:sldId id="273" r:id="rId19"/>
   </p:sldIdLst>
   <p:notesMasterIdLst>
-    <p:notesMasterId r:id="rId19"/>
+    <p:notesMasterId r:id="rId20"/>
   </p:notesMasterIdLst>
   <p:sldSz cx="12191695" cy="6858000"/>
   <p:notesSz cx="6858000" cy="12191695"/>
@@ -1246,6 +1247,94 @@
             <a:fld id="{F7021451-1387-4CA6-816F-3879F97B5CBC}" type="slidenum">
               <a:rPr lang="en-US"/>
               <a:t>17</a:t>
+            </a:fld>
+            <a:endParaRPr lang="en-US"/>
+          </a:p>
+        </p:txBody>
+      </p:sp>
+    </p:spTree>
+    <p:extLst>
+      <p:ext uri="{BB962C8B-B14F-4D97-AF65-F5344CB8AC3E}">
+        <p14:creationId xmlns:p14="http://schemas.microsoft.com/office/powerpoint/2010/main" val="1024086991"/>
+      </p:ext>
+    </p:extLst>
+  </p:cSld>
+  <p:clrMapOvr>
+    <a:masterClrMapping/>
+  </p:clrMapOvr>
+</p:notes>
+</file>
+
+<file path=ppt/notesSlides/notesSlide18.xml><?xml version="1.0" encoding="utf-8"?>
+<p:notes xmlns:a="http://schemas.openxmlformats.org/drawingml/2006/main" xmlns:r="http://schemas.openxmlformats.org/officeDocument/2006/relationships" xmlns:p="http://schemas.openxmlformats.org/presentationml/2006/main">
+  <p:cSld>
+    <p:spTree>
+      <p:nvGrpSpPr>
+        <p:cNvPr id="1" name=""/>
+        <p:cNvGrpSpPr/>
+        <p:nvPr/>
+      </p:nvGrpSpPr>
+      <p:grpSpPr>
+        <a:xfrm>
+          <a:off x="0" y="0"/>
+          <a:ext cx="0" cy="0"/>
+          <a:chOff x="0" y="0"/>
+          <a:chExt cx="0" cy="0"/>
+        </a:xfrm>
+      </p:grpSpPr>
+      <p:sp>
+        <p:nvSpPr>
+          <p:cNvPr id="2" name="Slide Image Placeholder 1"/>
+          <p:cNvSpPr>
+            <a:spLocks noGrp="1" noRot="1" noChangeAspect="1"/>
+          </p:cNvSpPr>
+          <p:nvPr>
+            <p:ph type="sldImg"/>
+          </p:nvPr>
+        </p:nvSpPr>
+        <p:spPr/>
+      </p:sp>
+      <p:sp>
+        <p:nvSpPr>
+          <p:cNvPr id="3" name="Notes Placeholder 2"/>
+          <p:cNvSpPr>
+            <a:spLocks noGrp="1"/>
+          </p:cNvSpPr>
+          <p:nvPr>
+            <p:ph type="body" idx="1"/>
+          </p:nvPr>
+        </p:nvSpPr>
+        <p:spPr/>
+        <p:txBody>
+          <a:bodyPr/>
+          <a:lstStyle/>
+          <a:p>
+            <a:r>
+              <a:rPr lang="en-US" dirty="0"/>
+              <a:t>That's where to go next. The two codes carry the talk home: on the left, the reference architecture itself — the site, the runnable Quarkus domain services, the contracts and schema catalog, and the single-command minikube bootstrap that stands the whole mesh up on a laptop. On the right, the Workshops and Tutorials hub: every workshop, tutorial, and deck in the series in one place, including the 201 deep-dive. Scan whichever is useful; both are public on the Pattern Catalyst GitHub organization.</a:t>
+            </a:r>
+            <a:endParaRPr lang="en-US" dirty="0"/>
+          </a:p>
+        </p:txBody>
+      </p:sp>
+      <p:sp>
+        <p:nvSpPr>
+          <p:cNvPr id="4" name="Slide Number Placeholder 3"/>
+          <p:cNvSpPr>
+            <a:spLocks noGrp="1"/>
+          </p:cNvSpPr>
+          <p:nvPr>
+            <p:ph type="sldNum" sz="quarter" idx="10"/>
+          </p:nvPr>
+        </p:nvSpPr>
+        <p:spPr/>
+        <p:txBody>
+          <a:bodyPr/>
+          <a:lstStyle/>
+          <a:p>
+            <a:fld id="{F7021451-1387-4CA6-816F-3879F97B5CBC}" type="slidenum">
+              <a:rPr lang="en-US"/>
+              <a:t>18</a:t>
             </a:fld>
             <a:endParaRPr lang="en-US"/>
           </a:p>
@@ -3295,8 +3384,8 @@
         </p:blipFill>
         <p:spPr>
           <a:xfrm>
-            <a:off x="1221100" y="1645920"/>
-            <a:ext cx="9749496" cy="3931920"/>
+            <a:off x="2413324" y="1645920"/>
+            <a:ext cx="7365048" cy="3931920"/>
           </a:xfrm>
           <a:prstGeom prst="rect">
             <a:avLst/>
@@ -4464,6 +4553,461 @@
           </a:prstGeom>
         </p:spPr>
       </p:pic>
+    </p:spTree>
+  </p:cSld>
+  <p:clrMapOvr>
+    <a:masterClrMapping/>
+  </p:clrMapOvr>
+</p:sld>
+</file>
+
+<file path=ppt/slides/slide18.xml><?xml version="1.0" encoding="utf-8"?>
+<p:sld xmlns:a="http://schemas.openxmlformats.org/drawingml/2006/main" xmlns:r="http://schemas.openxmlformats.org/officeDocument/2006/relationships" xmlns:p="http://schemas.openxmlformats.org/presentationml/2006/main">
+  <p:cSld name="Slide 18">
+    <p:bg>
+      <p:bgPr>
+        <a:solidFill>
+          <a:srgbClr val="FFFFFF"/>
+        </a:solidFill>
+      </p:bgPr>
+    </p:bg>
+    <p:spTree>
+      <p:nvGrpSpPr>
+        <p:cNvPr id="1" name=""/>
+        <p:cNvGrpSpPr/>
+        <p:nvPr/>
+      </p:nvGrpSpPr>
+      <p:grpSpPr>
+        <a:xfrm>
+          <a:off x="0" y="0"/>
+          <a:ext cx="0" cy="0"/>
+          <a:chOff x="0" y="0"/>
+          <a:chExt cx="0" cy="0"/>
+        </a:xfrm>
+      </p:grpSpPr>
+      <p:sp>
+        <p:nvSpPr>
+          <p:cNvPr id="2" name="Text 0"/>
+          <p:cNvSpPr/>
+          <p:nvPr/>
+        </p:nvSpPr>
+        <p:spPr>
+          <a:xfrm>
+            <a:off x="457200" y="6400800"/>
+            <a:ext cx="914400" cy="274320"/>
+          </a:xfrm>
+          <a:prstGeom prst="rect">
+            <a:avLst/>
+          </a:prstGeom>
+          <a:noFill/>
+          <a:ln/>
+        </p:spPr>
+        <p:txBody>
+          <a:bodyPr wrap="square" lIns="0" tIns="0" rIns="0" bIns="0" rtlCol="0" anchor="ctr"/>
+          <a:lstStyle/>
+          <a:p>
+            <a:pPr algn="l" indent="0" marL="0">
+              <a:buNone/>
+            </a:pPr>
+            <a:r>
+              <a:rPr lang="en-US" sz="1000" dirty="0">
+                <a:solidFill>
+                  <a:srgbClr val="8A8A8A"/>
+                </a:solidFill>
+                <a:latin typeface="Red Hat Text" pitchFamily="34" charset="0"/>
+                <a:ea typeface="Red Hat Text" pitchFamily="34" charset="-122"/>
+                <a:cs typeface="Red Hat Text" pitchFamily="34" charset="-120"/>
+              </a:rPr>
+              <a:t>17</a:t>
+            </a:r>
+            <a:endParaRPr lang="en-US" sz="1000" dirty="0"/>
+          </a:p>
+        </p:txBody>
+      </p:sp>
+      <p:pic>
+        <p:nvPicPr>
+          <p:cNvPr id="3" name="Image 0" descr="brand-logo-dark.png">    </p:cNvPr>
+          <p:cNvPicPr>
+            <a:picLocks noChangeAspect="1"/>
+          </p:cNvPicPr>
+          <p:nvPr/>
+        </p:nvPicPr>
+        <p:blipFill>
+          <a:blip r:embed="rId1"/>
+          <a:stretch>
+            <a:fillRect/>
+          </a:stretch>
+        </p:blipFill>
+        <p:spPr>
+          <a:xfrm>
+            <a:off x="10591495" y="6353919"/>
+            <a:ext cx="1051560" cy="248049"/>
+          </a:xfrm>
+          <a:prstGeom prst="rect">
+            <a:avLst/>
+          </a:prstGeom>
+        </p:spPr>
+      </p:pic>
+      <p:sp>
+        <p:nvSpPr>
+          <p:cNvPr id="4" name="Text 1"/>
+          <p:cNvSpPr/>
+          <p:nvPr/>
+        </p:nvSpPr>
+        <p:spPr>
+          <a:xfrm>
+            <a:off x="640080" y="411480"/>
+            <a:ext cx="10911535" cy="292608"/>
+          </a:xfrm>
+          <a:prstGeom prst="rect">
+            <a:avLst/>
+          </a:prstGeom>
+          <a:noFill/>
+          <a:ln/>
+        </p:spPr>
+        <p:txBody>
+          <a:bodyPr wrap="square" lIns="0" tIns="0" rIns="0" bIns="0" rtlCol="0" anchor="ctr"/>
+          <a:lstStyle/>
+          <a:p>
+            <a:pPr indent="0" marL="0">
+              <a:buNone/>
+            </a:pPr>
+            <a:r>
+              <a:rPr lang="en-US" sz="1200" b="1" spc="200" kern="0" dirty="0">
+                <a:solidFill>
+                  <a:srgbClr val="EE0000"/>
+                </a:solidFill>
+                <a:latin typeface="Overpass SemiBold" pitchFamily="34" charset="0"/>
+                <a:ea typeface="Overpass SemiBold" pitchFamily="34" charset="-122"/>
+                <a:cs typeface="Overpass SemiBold" pitchFamily="34" charset="-120"/>
+              </a:rPr>
+              <a:t>SCAN TO EXPLORE</a:t>
+            </a:r>
+            <a:endParaRPr lang="en-US" sz="1200" dirty="0"/>
+          </a:p>
+        </p:txBody>
+      </p:sp>
+      <p:sp>
+        <p:nvSpPr>
+          <p:cNvPr id="5" name="Text 2"/>
+          <p:cNvSpPr/>
+          <p:nvPr/>
+        </p:nvSpPr>
+        <p:spPr>
+          <a:xfrm>
+            <a:off x="640080" y="713232"/>
+            <a:ext cx="10911535" cy="868680"/>
+          </a:xfrm>
+          <a:prstGeom prst="rect">
+            <a:avLst/>
+          </a:prstGeom>
+          <a:noFill/>
+          <a:ln/>
+        </p:spPr>
+        <p:txBody>
+          <a:bodyPr wrap="square" lIns="0" tIns="0" rIns="0" bIns="0" rtlCol="0" anchor="t"/>
+          <a:lstStyle/>
+          <a:p>
+            <a:pPr indent="0" marL="0">
+              <a:buNone/>
+            </a:pPr>
+            <a:r>
+              <a:rPr lang="en-US" sz="3000" b="1" dirty="0">
+                <a:solidFill>
+                  <a:srgbClr val="151515"/>
+                </a:solidFill>
+                <a:latin typeface="Overpass SemiBold" pitchFamily="34" charset="0"/>
+                <a:ea typeface="Overpass SemiBold" pitchFamily="34" charset="-122"/>
+                <a:cs typeface="Overpass SemiBold" pitchFamily="34" charset="-120"/>
+              </a:rPr>
+              <a:t>Take it with you</a:t>
+            </a:r>
+            <a:endParaRPr lang="en-US" sz="3000" dirty="0"/>
+          </a:p>
+        </p:txBody>
+      </p:sp>
+      <p:pic>
+        <p:nvPicPr>
+          <p:cNvPr id="6" name="Image 1" descr="qr-site.png">    </p:cNvPr>
+          <p:cNvPicPr>
+            <a:picLocks noChangeAspect="1"/>
+          </p:cNvPicPr>
+          <p:nvPr/>
+        </p:nvPicPr>
+        <p:blipFill>
+          <a:blip r:embed="rId2"/>
+          <a:stretch>
+            <a:fillRect/>
+          </a:stretch>
+        </p:blipFill>
+        <p:spPr>
+          <a:xfrm>
+            <a:off x="2103120" y="1783080"/>
+            <a:ext cx="2834640" cy="2834640"/>
+          </a:xfrm>
+          <a:prstGeom prst="rect">
+            <a:avLst/>
+          </a:prstGeom>
+        </p:spPr>
+      </p:pic>
+      <p:sp>
+        <p:nvSpPr>
+          <p:cNvPr id="7" name="Text 3"/>
+          <p:cNvSpPr/>
+          <p:nvPr/>
+        </p:nvSpPr>
+        <p:spPr>
+          <a:xfrm>
+            <a:off x="1417320" y="4754880"/>
+            <a:ext cx="4206240" cy="365760"/>
+          </a:xfrm>
+          <a:prstGeom prst="rect">
+            <a:avLst/>
+          </a:prstGeom>
+          <a:noFill/>
+          <a:ln/>
+        </p:spPr>
+        <p:txBody>
+          <a:bodyPr wrap="square" lIns="0" tIns="0" rIns="0" bIns="0" rtlCol="0" anchor="ctr"/>
+          <a:lstStyle/>
+          <a:p>
+            <a:pPr algn="ctr" indent="0" marL="0">
+              <a:buNone/>
+            </a:pPr>
+            <a:r>
+              <a:rPr lang="en-US" sz="1800" b="1" dirty="0">
+                <a:solidFill>
+                  <a:srgbClr val="151515"/>
+                </a:solidFill>
+                <a:latin typeface="Overpass SemiBold" pitchFamily="34" charset="0"/>
+                <a:ea typeface="Overpass SemiBold" pitchFamily="34" charset="-122"/>
+                <a:cs typeface="Overpass SemiBold" pitchFamily="34" charset="-120"/>
+              </a:rPr>
+              <a:t>The reference architecture</a:t>
+            </a:r>
+            <a:endParaRPr lang="en-US" sz="1800" dirty="0"/>
+          </a:p>
+        </p:txBody>
+      </p:sp>
+      <p:sp>
+        <p:nvSpPr>
+          <p:cNvPr id="8" name="Text 4"/>
+          <p:cNvSpPr/>
+          <p:nvPr/>
+        </p:nvSpPr>
+        <p:spPr>
+          <a:xfrm>
+            <a:off x="1325880" y="5138928"/>
+            <a:ext cx="4389120" cy="640080"/>
+          </a:xfrm>
+          <a:prstGeom prst="rect">
+            <a:avLst/>
+          </a:prstGeom>
+          <a:noFill/>
+          <a:ln/>
+        </p:spPr>
+        <p:txBody>
+          <a:bodyPr wrap="square" lIns="0" tIns="0" rIns="0" bIns="0" rtlCol="0" anchor="t"/>
+          <a:lstStyle/>
+          <a:p>
+            <a:pPr algn="ctr" indent="0" marL="0">
+              <a:buNone/>
+            </a:pPr>
+            <a:r>
+              <a:rPr lang="en-US" sz="1300" i="1" dirty="0">
+                <a:solidFill>
+                  <a:srgbClr val="5A5A5A"/>
+                </a:solidFill>
+                <a:latin typeface="Red Hat Text" pitchFamily="34" charset="0"/>
+                <a:ea typeface="Red Hat Text" pitchFamily="34" charset="-122"/>
+                <a:cs typeface="Red Hat Text" pitchFamily="34" charset="-120"/>
+              </a:rPr>
+              <a:t>Site, runnable Quarkus services, contracts, and the minikube bootstrap</a:t>
+            </a:r>
+            <a:endParaRPr lang="en-US" sz="1300" dirty="0"/>
+          </a:p>
+        </p:txBody>
+      </p:sp>
+      <p:sp>
+        <p:nvSpPr>
+          <p:cNvPr id="9" name="Text 5"/>
+          <p:cNvSpPr/>
+          <p:nvPr/>
+        </p:nvSpPr>
+        <p:spPr>
+          <a:xfrm>
+            <a:off x="1325880" y="5760720"/>
+            <a:ext cx="4389120" cy="292608"/>
+          </a:xfrm>
+          <a:prstGeom prst="rect">
+            <a:avLst/>
+          </a:prstGeom>
+          <a:noFill/>
+          <a:ln/>
+        </p:spPr>
+        <p:txBody>
+          <a:bodyPr wrap="square" lIns="0" tIns="0" rIns="0" bIns="0" rtlCol="0" anchor="ctr"/>
+          <a:lstStyle/>
+          <a:p>
+            <a:pPr algn="ctr" indent="0" marL="0">
+              <a:buNone/>
+            </a:pPr>
+            <a:r>
+              <a:rPr lang="en-US" sz="1000" dirty="0">
+                <a:solidFill>
+                  <a:srgbClr val="EE0000"/>
+                </a:solidFill>
+                <a:latin typeface="Red Hat Mono" pitchFamily="34" charset="0"/>
+                <a:ea typeface="Red Hat Mono" pitchFamily="34" charset="-122"/>
+                <a:cs typeface="Red Hat Mono" pitchFamily="34" charset="-120"/>
+              </a:rPr>
+              <a:t>patterncatalyst.github.io/datamesh-reference-arch-quarkus</a:t>
+            </a:r>
+            <a:endParaRPr lang="en-US" sz="1000" dirty="0"/>
+          </a:p>
+        </p:txBody>
+      </p:sp>
+      <p:pic>
+        <p:nvPicPr>
+          <p:cNvPr id="10" name="Image 2" descr="qr-hub.png">    </p:cNvPr>
+          <p:cNvPicPr>
+            <a:picLocks noChangeAspect="1"/>
+          </p:cNvPicPr>
+          <p:nvPr/>
+        </p:nvPicPr>
+        <p:blipFill>
+          <a:blip r:embed="rId3"/>
+          <a:stretch>
+            <a:fillRect/>
+          </a:stretch>
+        </p:blipFill>
+        <p:spPr>
+          <a:xfrm>
+            <a:off x="7251192" y="1783080"/>
+            <a:ext cx="2834640" cy="2834640"/>
+          </a:xfrm>
+          <a:prstGeom prst="rect">
+            <a:avLst/>
+          </a:prstGeom>
+        </p:spPr>
+      </p:pic>
+      <p:sp>
+        <p:nvSpPr>
+          <p:cNvPr id="11" name="Text 6"/>
+          <p:cNvSpPr/>
+          <p:nvPr/>
+        </p:nvSpPr>
+        <p:spPr>
+          <a:xfrm>
+            <a:off x="6565392" y="4754880"/>
+            <a:ext cx="4206240" cy="365760"/>
+          </a:xfrm>
+          <a:prstGeom prst="rect">
+            <a:avLst/>
+          </a:prstGeom>
+          <a:noFill/>
+          <a:ln/>
+        </p:spPr>
+        <p:txBody>
+          <a:bodyPr wrap="square" lIns="0" tIns="0" rIns="0" bIns="0" rtlCol="0" anchor="ctr"/>
+          <a:lstStyle/>
+          <a:p>
+            <a:pPr algn="ctr" indent="0" marL="0">
+              <a:buNone/>
+            </a:pPr>
+            <a:r>
+              <a:rPr lang="en-US" sz="1800" b="1" dirty="0">
+                <a:solidFill>
+                  <a:srgbClr val="151515"/>
+                </a:solidFill>
+                <a:latin typeface="Overpass SemiBold" pitchFamily="34" charset="0"/>
+                <a:ea typeface="Overpass SemiBold" pitchFamily="34" charset="-122"/>
+                <a:cs typeface="Overpass SemiBold" pitchFamily="34" charset="-120"/>
+              </a:rPr>
+              <a:t>Workshops &amp; Tutorials</a:t>
+            </a:r>
+            <a:endParaRPr lang="en-US" sz="1800" dirty="0"/>
+          </a:p>
+        </p:txBody>
+      </p:sp>
+      <p:sp>
+        <p:nvSpPr>
+          <p:cNvPr id="12" name="Text 7"/>
+          <p:cNvSpPr/>
+          <p:nvPr/>
+        </p:nvSpPr>
+        <p:spPr>
+          <a:xfrm>
+            <a:off x="6473952" y="5138928"/>
+            <a:ext cx="4389120" cy="640080"/>
+          </a:xfrm>
+          <a:prstGeom prst="rect">
+            <a:avLst/>
+          </a:prstGeom>
+          <a:noFill/>
+          <a:ln/>
+        </p:spPr>
+        <p:txBody>
+          <a:bodyPr wrap="square" lIns="0" tIns="0" rIns="0" bIns="0" rtlCol="0" anchor="t"/>
+          <a:lstStyle/>
+          <a:p>
+            <a:pPr algn="ctr" indent="0" marL="0">
+              <a:buNone/>
+            </a:pPr>
+            <a:r>
+              <a:rPr lang="en-US" sz="1300" i="1" dirty="0">
+                <a:solidFill>
+                  <a:srgbClr val="5A5A5A"/>
+                </a:solidFill>
+                <a:latin typeface="Red Hat Text" pitchFamily="34" charset="0"/>
+                <a:ea typeface="Red Hat Text" pitchFamily="34" charset="-122"/>
+                <a:cs typeface="Red Hat Text" pitchFamily="34" charset="-120"/>
+              </a:rPr>
+              <a:t>The whole series — every workshop, tutorial, and deck in one place</a:t>
+            </a:r>
+            <a:endParaRPr lang="en-US" sz="1300" dirty="0"/>
+          </a:p>
+        </p:txBody>
+      </p:sp>
+      <p:sp>
+        <p:nvSpPr>
+          <p:cNvPr id="13" name="Text 8"/>
+          <p:cNvSpPr/>
+          <p:nvPr/>
+        </p:nvSpPr>
+        <p:spPr>
+          <a:xfrm>
+            <a:off x="6382512" y="5760720"/>
+            <a:ext cx="4572000" cy="292608"/>
+          </a:xfrm>
+          <a:prstGeom prst="rect">
+            <a:avLst/>
+          </a:prstGeom>
+          <a:noFill/>
+          <a:ln/>
+        </p:spPr>
+        <p:txBody>
+          <a:bodyPr wrap="square" lIns="0" tIns="0" rIns="0" bIns="0" rtlCol="0" anchor="ctr"/>
+          <a:lstStyle/>
+          <a:p>
+            <a:pPr algn="ctr" indent="0" marL="0">
+              <a:buNone/>
+            </a:pPr>
+            <a:r>
+              <a:rPr lang="en-US" sz="900" dirty="0">
+                <a:solidFill>
+                  <a:srgbClr val="EE0000"/>
+                </a:solidFill>
+                <a:latin typeface="Red Hat Mono" pitchFamily="34" charset="0"/>
+                <a:ea typeface="Red Hat Mono" pitchFamily="34" charset="-122"/>
+                <a:cs typeface="Red Hat Mono" pitchFamily="34" charset="-120"/>
+              </a:rPr>
+              <a:t>patterncatalyst.github.io/patterncatalyst-workshops-tutorials-list</a:t>
+            </a:r>
+            <a:endParaRPr lang="en-US" sz="900" dirty="0"/>
+          </a:p>
+        </p:txBody>
+      </p:sp>
     </p:spTree>
   </p:cSld>
   <p:clrMapOvr>

</xml_diff>

<commit_message>
docs(site,deck,readme): extend advantages-of-moving + data-mesh value framing
Carry the enterprise / data-mesh framing from ch11 and the 201 deck into the rest
of the capability material:
- _docs/13-orchestration-styles, 14-ai-rules-triage, 16-websocket-scaling: add a
  'What you learned' point making the enterprise advantage and data-mesh value
  explicit (one Quarkus runtime for all three engines; auditable classify-then-
  decide; per-replica fan-out that makes KEDA scale-to-zero safe).
- README.md: a sentence framing the repo as Quarkus as the vehicle for
  implementing a data mesh in an enterprise.
- presentation/datamesh-101: enrich the two Quarkus teaser slides' speaker notes;
  rebuilt Datamesh_101-r1.1.pptx.

ch12 (Spring Boot comparison) already carries this framing. Voice scan clean
(0 ban-tier), jekyll build clean, forbidden-syntax OK.
</commit_message>
<xml_diff>
--- a/presentation/datamesh-101/Datamesh_101-r1.1.pptx
+++ b/presentation/datamesh-101/Datamesh_101-r1.1.pptx
@@ -871,7 +871,7 @@
           <a:p>
             <a:r>
               <a:rPr lang="en-US" dirty="0"/>
-              <a:t>This reference architecture uses Quarkus for every domain service (order, inventory, payment, shipping, notification, review) and demonstrates twelve capabilities, among them Panache for persistence, gRPC for typed inter-domain calls, GraphQL for a federated gateway, Reactive Messaging for Kafka-backed events, and WebSockets.Next for live pushes, with reactive and imperative handlers sharing one Vert.x reactor. The tour also covers the JDK 25 AOT cache, native image, OIDC, JBang, and Panama FFM. With fast boot and a small memory footprint, Quarkus gives a domain team a way to stand up a well-behaved data product without first becoming distributed-systems experts. This is a teaser — the full capability tour, with a Spring Boot twin service for a side-by-side comparison, is the centerpiece of the 201.</a:t>
+              <a:t>This reference architecture uses Quarkus for every domain service (order, inventory, payment, shipping, notification, review) and demonstrates twelve capabilities, among them Panache for persistence, gRPC for typed inter-domain calls, GraphQL for a federated gateway, Reactive Messaging for Kafka-backed events, and WebSockets.Next for live pushes, with reactive and imperative handlers sharing one Vert.x reactor. The tour also covers the JDK 25 AOT cache, native image, OIDC, JBang, and Panama FFM. With fast boot and a small memory footprint, Quarkus gives a domain team a way to stand up a well-behaved data product without first becoming distributed-systems experts, which is what makes it a credible vehicle for rolling a data mesh out across many enterprise teams. This is a teaser — the full capability tour, with a Spring Boot twin service for a side-by-side comparison, is the centerpiece of the 201.</a:t>
             </a:r>
             <a:endParaRPr lang="en-US" dirty="0"/>
           </a:p>
@@ -959,7 +959,7 @@
           <a:p>
             <a:r>
               <a:rPr lang="en-US" dirty="0"/>
-              <a:t>Every event-driven system eventually has to answer one question: when multiple steps need to happen in sequence, who decides the sequence? This build runs three answers side by side over the same shipping/order domain. Kafka choreography: no one is in charge — order-service publishes order.placed and has never heard of payment-service or shipping-service; each service only knows 'when I see event X, I do Y and emit Z.' Camel orchestration: one route explicitly sequences every step, imperative code you read top to bottom. Quarkus Flow orchestration: the same two steps expressed declaratively, as a workflow document rather than hand-written control flow — the same shape, two different engines. The 201 covers this comparison in full, using the terms choreography and orchestration exactly.</a:t>
+              <a:t>Every event-driven system eventually has to answer one question: when multiple steps need to happen in sequence, who decides the sequence? This build runs three answers side by side over the same shipping/order domain. Kafka choreography: no one is in charge — order-service publishes order.placed and has never heard of payment-service or shipping-service; each service only knows 'when I see event X, I do Y and emit Z.' Camel orchestration: one route explicitly sequences every step, imperative code you read top to bottom. Quarkus Flow orchestration: the same two steps expressed declaratively, as a workflow document rather than hand-written control flow — the same shape, two different engines. For an enterprise mesh the advantage is that all three run on one Quarkus runtime, so a domain team picks the coordination style that fits each step without standing up a separate workflow server or routing through a shared ESB. The 201 covers this comparison in full, using the terms choreography and orchestration exactly.</a:t>
             </a:r>
             <a:endParaRPr lang="en-US" dirty="0"/>
           </a:p>
@@ -3384,8 +3384,8 @@
         </p:blipFill>
         <p:spPr>
           <a:xfrm>
-            <a:off x="2413324" y="1645920"/>
-            <a:ext cx="7365048" cy="3931920"/>
+            <a:off x="1221100" y="1645920"/>
+            <a:ext cx="9749496" cy="3931920"/>
           </a:xfrm>
           <a:prstGeom prst="rect">
             <a:avLst/>

</xml_diff>

<commit_message>
docs(site,deck,readme): extend advantages-of-moving + data-mesh value framing (#60)
Carry the enterprise / data-mesh framing from ch11 and the 201 deck into the rest
of the capability material:
- _docs/13-orchestration-styles, 14-ai-rules-triage, 16-websocket-scaling: add a
  'What you learned' point making the enterprise advantage and data-mesh value
  explicit (one Quarkus runtime for all three engines; auditable classify-then-
  decide; per-replica fan-out that makes KEDA scale-to-zero safe).
- README.md: a sentence framing the repo as Quarkus as the vehicle for
  implementing a data mesh in an enterprise.
- presentation/datamesh-101: enrich the two Quarkus teaser slides' speaker notes;
  rebuilt Datamesh_101-r1.1.pptx.

ch12 (Spring Boot comparison) already carries this framing. Voice scan clean
(0 ban-tier), jekyll build clean, forbidden-syntax OK.
</commit_message>
<xml_diff>
--- a/presentation/datamesh-101/Datamesh_101-r1.1.pptx
+++ b/presentation/datamesh-101/Datamesh_101-r1.1.pptx
@@ -871,7 +871,7 @@
           <a:p>
             <a:r>
               <a:rPr lang="en-US" dirty="0"/>
-              <a:t>This reference architecture uses Quarkus for every domain service (order, inventory, payment, shipping, notification, review) and demonstrates twelve capabilities, among them Panache for persistence, gRPC for typed inter-domain calls, GraphQL for a federated gateway, Reactive Messaging for Kafka-backed events, and WebSockets.Next for live pushes, with reactive and imperative handlers sharing one Vert.x reactor. The tour also covers the JDK 25 AOT cache, native image, OIDC, JBang, and Panama FFM. With fast boot and a small memory footprint, Quarkus gives a domain team a way to stand up a well-behaved data product without first becoming distributed-systems experts. This is a teaser — the full capability tour, with a Spring Boot twin service for a side-by-side comparison, is the centerpiece of the 201.</a:t>
+              <a:t>This reference architecture uses Quarkus for every domain service (order, inventory, payment, shipping, notification, review) and demonstrates twelve capabilities, among them Panache for persistence, gRPC for typed inter-domain calls, GraphQL for a federated gateway, Reactive Messaging for Kafka-backed events, and WebSockets.Next for live pushes, with reactive and imperative handlers sharing one Vert.x reactor. The tour also covers the JDK 25 AOT cache, native image, OIDC, JBang, and Panama FFM. With fast boot and a small memory footprint, Quarkus gives a domain team a way to stand up a well-behaved data product without first becoming distributed-systems experts, which is what makes it a credible vehicle for rolling a data mesh out across many enterprise teams. This is a teaser — the full capability tour, with a Spring Boot twin service for a side-by-side comparison, is the centerpiece of the 201.</a:t>
             </a:r>
             <a:endParaRPr lang="en-US" dirty="0"/>
           </a:p>
@@ -959,7 +959,7 @@
           <a:p>
             <a:r>
               <a:rPr lang="en-US" dirty="0"/>
-              <a:t>Every event-driven system eventually has to answer one question: when multiple steps need to happen in sequence, who decides the sequence? This build runs three answers side by side over the same shipping/order domain. Kafka choreography: no one is in charge — order-service publishes order.placed and has never heard of payment-service or shipping-service; each service only knows 'when I see event X, I do Y and emit Z.' Camel orchestration: one route explicitly sequences every step, imperative code you read top to bottom. Quarkus Flow orchestration: the same two steps expressed declaratively, as a workflow document rather than hand-written control flow — the same shape, two different engines. The 201 covers this comparison in full, using the terms choreography and orchestration exactly.</a:t>
+              <a:t>Every event-driven system eventually has to answer one question: when multiple steps need to happen in sequence, who decides the sequence? This build runs three answers side by side over the same shipping/order domain. Kafka choreography: no one is in charge — order-service publishes order.placed and has never heard of payment-service or shipping-service; each service only knows 'when I see event X, I do Y and emit Z.' Camel orchestration: one route explicitly sequences every step, imperative code you read top to bottom. Quarkus Flow orchestration: the same two steps expressed declaratively, as a workflow document rather than hand-written control flow — the same shape, two different engines. For an enterprise mesh the advantage is that all three run on one Quarkus runtime, so a domain team picks the coordination style that fits each step without standing up a separate workflow server or routing through a shared ESB. The 201 covers this comparison in full, using the terms choreography and orchestration exactly.</a:t>
             </a:r>
             <a:endParaRPr lang="en-US" dirty="0"/>
           </a:p>
@@ -3384,8 +3384,8 @@
         </p:blipFill>
         <p:spPr>
           <a:xfrm>
-            <a:off x="2413324" y="1645920"/>
-            <a:ext cx="7365048" cy="3931920"/>
+            <a:off x="1221100" y="1645920"/>
+            <a:ext cx="9749496" cy="3931920"/>
           </a:xfrm>
           <a:prstGeom prst="rect">
             <a:avLst/>

</xml_diff>

<commit_message>
fix: reconcile ch03 to current order-service code + rebuild decks em-dash-clean
- ch03: update the placeOrder/OrderEventProducer code blocks and the #C
  callout to the current CDI-event pattern. order-service fires a CDI
  Event<Order> inside the @Transactional method and OrderEventProducer
  observes it with @Observes(during = AFTER_SUCCESS), so the Kafka publish
  runs only after commit. Replaces the stale eventProducer.publish(...)
  .exceptionally(...) inline shown before. The naive before-cut and the
  dual-write/outbox point are unchanged.
- Decks: remove em-dashes from both deck sources (one verbatim test string
  kept), re-raster figures, and rebuild both .pptx so they use the renamed
  final-project figures instead of the stale capstone rasters.

Verified: ch03 0 em-dash / 0 ban-tier, jekyll build clean, both deck builders
pass node -c and regenerate their pptx.
</commit_message>
<xml_diff>
--- a/presentation/datamesh-101/Datamesh_101-r1.1.pptx
+++ b/presentation/datamesh-101/Datamesh_101-r1.1.pptx
@@ -607,7 +607,7 @@
           <a:p>
             <a:r>
               <a:rPr lang="en-US" dirty="0"/>
-              <a:t>Domain ownership: data is owned end to end by the domain team that produces it; no central team 'owns the warehouse.' Data as a product: a data product is held to the same bar as any software product: discoverable, addressable, trustworthy, self-describing. It is not a renamed table. Self-serve data platform: domain teams shouldn't each build their own event streaming, observability, or registry; the platform provides that as shared infrastructure. Federated computational governance: standards are enforced computationally, by the platform, automatically — not by review meetings. All four together are what make a mesh a mesh rather than just a lot of disconnected microservices each hoarding their own data.</a:t>
+              <a:t>Domain ownership: data is owned end to end by the domain team that produces it; no central team 'owns the warehouse.' Data as a product: a data product is held to the same bar as any software product: discoverable, addressable, trustworthy, self-describing. It is not a renamed table. Self-serve data platform: domain teams shouldn't each build their own event streaming, observability, or registry; the platform provides that as shared infrastructure. Federated computational governance: standards are enforced computationally, by the platform, automatically, not by review meetings. All four together are what make a mesh a mesh rather than just a lot of disconnected microservices each hoarding their own data.</a:t>
             </a:r>
             <a:endParaRPr lang="en-US" dirty="0"/>
           </a:p>
@@ -695,7 +695,7 @@
           <a:p>
             <a:r>
               <a:rPr lang="en-US" dirty="0"/>
-              <a:t>The analogy for anyone who has been through a monolith-to-microservices transition. Just as a monolithic application gets refactored into bounded contexts owned by domain teams (the microservices transition many engineers have already lived through), a monolithic data platform gets refactored into bounded data products owned by those same domain teams. The mesh is the network of those products plus the platform and standards that let them interoperate. The hard part was never drawing the boxes; it was deciding where one bounded context ends and the next begins, and then living with the contract at that boundary. Decomposing a data platform into data products is the identical exercise, one layer up — the boundary is now a versioned data contract instead of a REST endpoint.</a:t>
+              <a:t>The analogy for anyone who has been through a monolith-to-microservices transition. Just as a monolithic application gets refactored into bounded contexts owned by domain teams (the microservices transition many engineers have already lived through), a monolithic data platform gets refactored into bounded data products owned by those same domain teams. The mesh is the network of those products plus the platform and standards that let them interoperate. The hard part was never drawing the boxes; it was deciding where one bounded context ends and the next begins, and then living with the contract at that boundary. Decomposing a data platform into data products is the identical exercise, one layer up: the boundary is now a versioned data contract instead of a REST endpoint.</a:t>
             </a:r>
             <a:endParaRPr lang="en-US" dirty="0"/>
           </a:p>
@@ -783,7 +783,7 @@
           <a:p>
             <a:r>
               <a:rPr lang="en-US" dirty="0"/>
-              <a:t>Now let's bring this back to the room. Why build a data mesh on Quarkus and Kubernetes specifically? Because Quarkus gives a single, coherent developer experience across every protocol a domain service needs (REST, gRPC, GraphQL, Kafka) without ten disconnected quickstarts, and Kubernetes's primitives map onto the four principles unusually cleanly: namespaces for domain ownership, Deployments and CRDs for data as a product, operators for the self-serve platform, and mesh/admission policy for federated governance. This section is a fast teaser — the depth lives in the 201.</a:t>
+              <a:t>Now let's bring this back to the room. Why build a data mesh on Quarkus and Kubernetes specifically? Because Quarkus gives a single, coherent developer experience across every protocol a domain service needs (REST, gRPC, GraphQL, Kafka) without ten disconnected quickstarts, and Kubernetes's primitives map onto the four principles unusually cleanly: namespaces for domain ownership, Deployments and CRDs for data as a product, operators for the self-serve platform, and mesh/admission policy for federated governance. This section is a fast teaser; the depth lives in the 201.</a:t>
             </a:r>
             <a:endParaRPr lang="en-US" dirty="0"/>
           </a:p>
@@ -871,7 +871,7 @@
           <a:p>
             <a:r>
               <a:rPr lang="en-US" dirty="0"/>
-              <a:t>This reference architecture uses Quarkus for every domain service (order, inventory, payment, shipping, notification, review) and demonstrates twelve capabilities, among them Panache for persistence, gRPC for typed inter-domain calls, GraphQL for a federated gateway, Reactive Messaging for Kafka-backed events, and WebSockets.Next for live pushes, with reactive and imperative handlers sharing one Vert.x reactor. The tour also covers the JDK 25 AOT cache, native image, OIDC, JBang, and Panama FFM. With fast boot and a small memory footprint, Quarkus gives a domain team a way to stand up a well-behaved data product without first becoming distributed-systems experts, which is what makes it a credible vehicle for rolling a data mesh out across many enterprise teams. This is a teaser — the full capability tour, with a Spring Boot twin service for a side-by-side comparison, is the centerpiece of the 201.</a:t>
+              <a:t>This reference architecture uses Quarkus for every domain service (order, inventory, payment, shipping, notification, review) and demonstrates twelve capabilities, among them Panache for persistence, gRPC for typed inter-domain calls, GraphQL for a federated gateway, Reactive Messaging for Kafka-backed events, and WebSockets.Next for live pushes, with reactive and imperative handlers sharing one Vert.x reactor. The tour also covers the JDK 25 AOT cache, native image, OIDC, JBang, and Panama FFM. With fast boot and a small memory footprint, Quarkus gives a domain team a way to stand up a well-behaved data product without first becoming distributed-systems experts, which is what makes it a credible vehicle for rolling a data mesh out across many enterprise teams. This is a teaser; the full capability tour, with a Spring Boot twin service for a side-by-side comparison, is the centerpiece of the 201.</a:t>
             </a:r>
             <a:endParaRPr lang="en-US" dirty="0"/>
           </a:p>
@@ -959,7 +959,7 @@
           <a:p>
             <a:r>
               <a:rPr lang="en-US" dirty="0"/>
-              <a:t>Every event-driven system eventually has to answer one question: when multiple steps need to happen in sequence, who decides the sequence? This build runs three answers side by side over the same shipping/order domain. Kafka choreography: no one is in charge — order-service publishes order.placed and has never heard of payment-service or shipping-service; each service only knows 'when I see event X, I do Y and emit Z.' Camel orchestration: one route explicitly sequences every step, imperative code you read top to bottom. Quarkus Flow orchestration: the same two steps expressed declaratively, as a workflow document rather than hand-written control flow — the same shape, two different engines. For an enterprise mesh the advantage is that all three run on one Quarkus runtime, so a domain team picks the coordination style that fits each step without standing up a separate workflow server or routing through a shared ESB. The 201 covers this comparison in full, using the terms choreography and orchestration exactly.</a:t>
+              <a:t>Every event-driven system eventually has to answer one question: when multiple steps need to happen in sequence, who decides the sequence? This build runs three answers side by side over the same shipping/order domain. Kafka choreography: no one is in charge; order-service publishes order.placed and has never heard of payment-service or shipping-service; each service only knows 'when I see event X, I do Y and emit Z.' Camel orchestration: one route explicitly sequences every step, imperative code you read top to bottom. Quarkus Flow orchestration: the same two steps expressed declaratively, as a workflow document rather than hand-written control flow; the same shape, two different engines. For an enterprise mesh the advantage is that all three run on one Quarkus runtime, so a domain team picks the coordination style that fits each step without standing up a separate workflow server or routing through a shared ESB. The 201 covers this comparison in full, using the terms choreography and orchestration exactly.</a:t>
             </a:r>
             <a:endParaRPr lang="en-US" dirty="0"/>
           </a:p>
@@ -1311,7 +1311,7 @@
           <a:p>
             <a:r>
               <a:rPr lang="en-US" dirty="0"/>
-              <a:t>That's where to go next. The two codes carry the talk home: on the left, the reference architecture itself — the site, the runnable Quarkus domain services, the contracts and schema catalog, and the single-command minikube bootstrap that stands the whole mesh up on a laptop. On the right, the Workshops and Tutorials hub: every workshop, tutorial, and deck in the series in one place, including the 201 deep-dive. Scan whichever is useful; both are public on the Pattern Catalyst GitHub organization.</a:t>
+              <a:t>That's where to go next. The two codes carry the talk home: on the left, the reference architecture itself: the site, the runnable Quarkus domain services, the contracts and schema catalog, and the single-command minikube bootstrap that stands the whole mesh up on a laptop. On the right, the Workshops and Tutorials hub: every workshop, tutorial, and deck in the series in one place, including the 201 deep-dive. Scan whichever is useful; both are public on the Pattern Catalyst GitHub organization.</a:t>
             </a:r>
             <a:endParaRPr lang="en-US" dirty="0"/>
           </a:p>
@@ -1399,7 +1399,7 @@
           <a:p>
             <a:r>
               <a:rPr lang="en-US" dirty="0"/>
-              <a:t>Before we can appreciate what a data mesh is, we need to see what came before it. Every pattern in this section — pipelines, warehouses, lakes — solved a real problem for its era. None of them is wrong. The mesh does not replace all of them; it responds to a specific organizational scaling problem that none of them fully solves. We'll walk through each pattern quickly, then see how they led to the mesh.</a:t>
+              <a:t>Before we can appreciate what a data mesh is, we need to see what came before it. Every pattern in this section (pipelines, warehouses, lakes) solved a real problem for its era. None of them is wrong. The mesh does not replace all of them; it responds to a specific organizational scaling problem that none of them fully solves. We'll walk through each pattern quickly, then see how they led to the mesh.</a:t>
             </a:r>
             <a:endParaRPr lang="en-US" dirty="0"/>
           </a:p>
@@ -1487,7 +1487,7 @@
           <a:p>
             <a:r>
               <a:rPr lang="en-US" dirty="0"/>
-              <a:t>The oldest data architecture problem is movement: operational systems produce data, analytical systems consume it, and something has to get it from one to the other. A pipeline is that something — ETL or ELT, it doesn't matter which, both are linear, bespoke, point-to-point flows from a known source to a known destination. The limitation is pipeline sprawl: each new source or destination doesn't add one pipeline, it adds as many as there are things on the other side. Nobody owns the data flowing through a pipeline — it's plumbing, not a product. That's the seed of everything that follows.</a:t>
+              <a:t>The oldest data architecture problem is movement: operational systems produce data, analytical systems consume it, and something has to get it from one to the other. A pipeline is that something: ETL or ELT, it doesn't matter which, both are linear, bespoke, point-to-point flows from a known source to a known destination. The limitation is pipeline sprawl: each new source or destination doesn't add one pipeline, it adds as many as there are things on the other side. Nobody owns the data flowing through a pipeline; it's plumbing, not a product. That's the seed of everything that follows.</a:t>
             </a:r>
             <a:endParaRPr lang="en-US" dirty="0"/>
           </a:p>
@@ -1575,7 +1575,7 @@
           <a:p>
             <a:r>
               <a:rPr lang="en-US" dirty="0"/>
-              <a:t>The warehouse solved the truth problem pipeline sprawl created: instead of every consumer building its own understanding from raw pipeline output, everyone queries the same curated, schema-on-write model. The limitation is organizational, not technical — a central data team owns all the data but understands none of the domains it came from. Every schema change, every new source funnels through that one team, and as the organization grows, the queue becomes the bottleneck. This is the bottleneck a data mesh exists to remove — not by building a better warehouse, but by changing who owns the data.</a:t>
+              <a:t>The warehouse solved the truth problem pipeline sprawl created: instead of every consumer building its own understanding from raw pipeline output, everyone queries the same curated, schema-on-write model. The limitation is organizational, not technical: a central data team owns all the data but understands none of the domains it came from. Every schema change, every new source funnels through that one team, and as the organization grows, the queue becomes the bottleneck. This is the bottleneck a data mesh exists to remove, not by building a better warehouse, but by changing who owns the data.</a:t>
             </a:r>
             <a:endParaRPr lang="en-US" dirty="0"/>
           </a:p>
@@ -1663,7 +1663,7 @@
           <a:p>
             <a:r>
               <a:rPr lang="en-US" dirty="0"/>
-              <a:t>The lake solved the warehouse's format rigidity — it accepts structured, semi-structured, unstructured, and streaming data, and defers schema decisions to the point of consumption, schema-on-read instead of schema-on-write. Zone-based organization (raw, curated, refined) is how well-run lakes stay usable. But without active curation, the lake becomes a data swamp: undocumented, stale, duplicated datasets nobody trusts. And notice what didn't change — a central team still owns the bucket. The lake fixed the format problem, not the organizational one.</a:t>
+              <a:t>The lake solved the warehouse's format rigidity: it accepts structured, semi-structured, unstructured, and streaming data, and defers schema decisions to the point of consumption, schema-on-read instead of schema-on-write. Zone-based organization (raw, curated, refined) is how well-run lakes stay usable. But without active curation, the lake becomes a data swamp: undocumented, stale, duplicated datasets nobody trusts. And notice what didn't change: a central team still owns the bucket. The lake fixed the format problem, not the organizational one.</a:t>
             </a:r>
             <a:endParaRPr lang="en-US" dirty="0"/>
           </a:p>
@@ -1751,7 +1751,7 @@
           <a:p>
             <a:r>
               <a:rPr lang="en-US" dirty="0"/>
-              <a:t>One more distinction underlies everything before we get to the mesh itself. Operational data is the current-state data behind a domain's running services — the rows a microservice reads and writes to do its job. Analytical data is the historical, aggregated view used for decisions and models. Traditionally these live in separate worlds joined by a tangle of ETL on a delay — all operational data here, all analytical data there, pipelines between. A data mesh doesn't erase that distinction, but reorganizes it by domain rather than by technology layer: each domain owns both its operational systems and the analytical products derived from them. That is the seam the mesh closes.</a:t>
+              <a:t>One more distinction underlies everything before we get to the mesh itself. Operational data is the current-state data behind a domain's running services: the rows a microservice reads and writes to do its job. Analytical data is the historical, aggregated view used for decisions and models. Traditionally these live in separate worlds joined by a tangle of ETL on a delay: all operational data here, all analytical data there, pipelines between. A data mesh doesn't erase that distinction, but reorganizes it by domain rather than by technology layer: each domain owns both its operational systems and the analytical products derived from them. That is the seam the mesh closes.</a:t>
             </a:r>
             <a:endParaRPr lang="en-US" dirty="0"/>
           </a:p>
@@ -1839,7 +1839,7 @@
           <a:p>
             <a:r>
               <a:rPr lang="en-US" dirty="0"/>
-              <a:t>This is the pivot. All three prior patterns (pipelines, warehouses, lakes) centralize data and hand ownership to a single team; the technology improves generation by generation but the organizational shape stays the same. The mesh changes the axis: instead of building a better center, decentralize ownership to the domains that produce the data. Each domain owns its data as a product that is discoverable, addressable, trustworthy, and self-describing, and talks to other domains directly. A shared self-serve platform provides the infrastructure underneath, and federated computational governance keeps the independently-owned products interoperable. Notice there's no 'central data team' card on this diagram at all — that's the point.</a:t>
+              <a:t>This is the pivot. All three prior patterns (pipelines, warehouses, lakes) centralize data and hand ownership to a single team; the technology improves generation by generation but the organizational shape stays the same. The mesh changes the axis: instead of building a better center, decentralize ownership to the domains that produce the data. Each domain owns its data as a product that is discoverable, addressable, trustworthy, and self-describing, and talks to other domains directly. A shared self-serve platform provides the infrastructure underneath, and federated computational governance keeps the independently-owned products interoperable. Notice there's no 'central data team' card on this diagram at all; that's the point.</a:t>
             </a:r>
             <a:endParaRPr lang="en-US" dirty="0"/>
           </a:p>
@@ -2015,7 +2015,7 @@
           <a:p>
             <a:r>
               <a:rPr lang="en-US" dirty="0"/>
-              <a:t>With the landscape in place, let's define data mesh. Zhamak Dehghani coined the term in 2019 and formalized it in her 2022 O'Reilly book. It rests on four interlocking principles that depend on each other — implement one without the others and you get a distributed mess, not a mesh. We'll look at all four together, then at the analogy that makes them concrete for anyone who has lived through a monolith-to-microservices transition: the same decomposition, applied to data ownership instead of application code.</a:t>
+              <a:t>With the landscape in place, let's define data mesh. Zhamak Dehghani coined the term in 2019 and formalized it in her 2022 O'Reilly book. It rests on four interlocking principles that depend on each other; implement one without the others and you get a distributed mess, not a mesh. We'll look at all four together, then at the analogy that makes them concrete for anyone who has lived through a monolith-to-microservices transition: the same decomposition, applied to data ownership instead of application code.</a:t>
             </a:r>
             <a:endParaRPr lang="en-US" dirty="0"/>
           </a:p>
@@ -2525,7 +2525,7 @@
                 <a:ea typeface="Red Hat Text" pitchFamily="34" charset="-122"/>
                 <a:cs typeface="Red Hat Text" pitchFamily="34" charset="-120"/>
               </a:rPr>
-              <a:t>From data-mesh principles to a running platform on Quarkus and Kubernetes — no Quarkus experience assumed</a:t>
+              <a:t>From data-mesh principles to a running platform on Quarkus and Kubernetes (no Quarkus experience assumed)</a:t>
             </a:r>
             <a:endParaRPr lang="en-US" sz="1700" dirty="0"/>
           </a:p>
@@ -2761,7 +2761,7 @@
                 <a:ea typeface="Red Hat Text" pitchFamily="34" charset="-122"/>
                 <a:cs typeface="Red Hat Text" pitchFamily="34" charset="-120"/>
               </a:rPr>
-              <a:t>The four principles depend on each other — implement one without the others and you get a distributed mess, not a mesh.</a:t>
+              <a:t>The four principles depend on each other; implement one without the others and you get a distributed mess, not a mesh.</a:t>
             </a:r>
             <a:endParaRPr lang="en-US" sz="1250" dirty="0"/>
           </a:p>
@@ -3425,7 +3425,7 @@
                 <a:ea typeface="Red Hat Text" pitchFamily="34" charset="-122"/>
                 <a:cs typeface="Red Hat Text" pitchFamily="34" charset="-120"/>
               </a:rPr>
-              <a:t>REST, gRPC, GraphQL, Kafka, reactive and imperative in one JVM, fast boot, low memory — one coherent toolchain across every data-product surface.</a:t>
+              <a:t>REST, gRPC, GraphQL, Kafka, reactive and imperative in one JVM, fast boot, low memory: one coherent toolchain across every data-product surface.</a:t>
             </a:r>
             <a:endParaRPr lang="en-US" sz="1250" dirty="0"/>
           </a:p>
@@ -3598,7 +3598,7 @@
                 <a:ea typeface="Overpass SemiBold" pitchFamily="34" charset="-122"/>
                 <a:cs typeface="Overpass SemiBold" pitchFamily="34" charset="-120"/>
               </a:rPr>
-              <a:t>Choreography vs. orchestration — one domain, three coordination engines</a:t>
+              <a:t>Choreography vs. orchestration: one domain, three coordination engines</a:t>
             </a:r>
             <a:endParaRPr lang="en-US" sz="3000" dirty="0"/>
           </a:p>
@@ -3842,7 +3842,7 @@
       </p:sp>
       <p:pic>
         <p:nvPicPr>
-          <p:cNvPr id="4" name="Image 0" descr="dpng/02-capstone-data-mesh.png">    </p:cNvPr>
+          <p:cNvPr id="4" name="Image 0" descr="dpng/02-final-project-data-mesh.png">    </p:cNvPr>
           <p:cNvPicPr>
             <a:picLocks noChangeAspect="1"/>
           </p:cNvPicPr>
@@ -4116,7 +4116,7 @@
                 <a:ea typeface="Red Hat Text" pitchFamily="34" charset="-122"/>
                 <a:cs typeface="Red Hat Text" pitchFamily="34" charset="-120"/>
               </a:rPr>
-              <a:t>The choice depends on scale, data landscape, and where the bottleneck sits — not on which pattern is newest. A data mesh is not always the answer.</a:t>
+              <a:t>The choice depends on scale, data landscape, and where the bottleneck sits, not on which pattern is newest. A data mesh is not always the answer.</a:t>
             </a:r>
             <a:endParaRPr lang="en-US" sz="1600" dirty="0"/>
           </a:p>
@@ -4292,7 +4292,7 @@
                 <a:ea typeface="Red Hat Text" pitchFamily="34" charset="-122"/>
                 <a:cs typeface="Red Hat Text" pitchFamily="34" charset="-120"/>
               </a:rPr>
-              <a:t>Many domains, many consumers, and a central team has become the constraint — and the organization has the maturity to operate federated ownership.</a:t>
+              <a:t>Many domains, many consumers, and a central team has become the constraint, and the organization has the maturity to operate federated ownership.</a:t>
             </a:r>
             <a:endParaRPr lang="en-US" sz="1600" dirty="0"/>
           </a:p>
@@ -4963,7 +4963,7 @@
                 <a:ea typeface="Red Hat Text" pitchFamily="34" charset="-122"/>
                 <a:cs typeface="Red Hat Text" pitchFamily="34" charset="-120"/>
               </a:rPr>
-              <a:t>The whole series — every workshop, tutorial, and deck in one place</a:t>
+              <a:t>The whole series: every workshop, tutorial, and deck in one place</a:t>
             </a:r>
             <a:endParaRPr lang="en-US" sz="1300" dirty="0"/>
           </a:p>
@@ -5170,7 +5170,7 @@
                 <a:ea typeface="Red Hat Text" pitchFamily="34" charset="-122"/>
                 <a:cs typeface="Red Hat Text" pitchFamily="34" charset="-120"/>
               </a:rPr>
-              <a:t>Four data architectures — what each pattern solves and the limitation it leaves behind.</a:t>
+              <a:t>Four data architectures: what each pattern solves and the limitation it leaves behind.</a:t>
             </a:r>
             <a:endParaRPr lang="en-US" sz="1600" dirty="0"/>
           </a:p>
@@ -5304,7 +5304,7 @@
                 <a:ea typeface="Overpass SemiBold" pitchFamily="34" charset="-122"/>
                 <a:cs typeface="Overpass SemiBold" pitchFamily="34" charset="-120"/>
               </a:rPr>
-              <a:t>Data pipelines — the plumbing</a:t>
+              <a:t>Data pipelines: the plumbing</a:t>
             </a:r>
             <a:endParaRPr lang="en-US" sz="3000" dirty="0"/>
           </a:p>
@@ -5540,7 +5540,7 @@
                 <a:ea typeface="Overpass SemiBold" pitchFamily="34" charset="-122"/>
                 <a:cs typeface="Overpass SemiBold" pitchFamily="34" charset="-120"/>
               </a:rPr>
-              <a:t>Data warehouses — many sources, one team, one store</a:t>
+              <a:t>Data warehouses: many sources, one team, one store</a:t>
             </a:r>
             <a:endParaRPr lang="en-US" sz="3000" dirty="0"/>
           </a:p>
@@ -5603,7 +5603,7 @@
                 <a:ea typeface="Red Hat Text" pitchFamily="34" charset="-122"/>
                 <a:cs typeface="Red Hat Text" pitchFamily="34" charset="-120"/>
               </a:rPr>
-              <a:t>A centralized, governed analytical store — and the central team that owns it becomes the single point of contention.</a:t>
+              <a:t>A centralized, governed analytical store, and the central team that owns it becomes the single point of contention.</a:t>
             </a:r>
             <a:endParaRPr lang="en-US" sz="1250" dirty="0"/>
           </a:p>
@@ -5776,7 +5776,7 @@
                 <a:ea typeface="Overpass SemiBold" pitchFamily="34" charset="-122"/>
                 <a:cs typeface="Overpass SemiBold" pitchFamily="34" charset="-120"/>
               </a:rPr>
-              <a:t>Data lakes — flexible on the way in, swamp risk on the way out</a:t>
+              <a:t>Data lakes: flexible on the way in, swamp risk on the way out</a:t>
             </a:r>
             <a:endParaRPr lang="en-US" sz="3000" dirty="0"/>
           </a:p>
@@ -5839,7 +5839,7 @@
                 <a:ea typeface="Red Hat Text" pitchFamily="34" charset="-122"/>
                 <a:cs typeface="Red Hat Text" pitchFamily="34" charset="-120"/>
               </a:rPr>
-              <a:t>Raw, curated, refined zones accept any format — but without governance the lake becomes a swamp, and the central-team bottleneck remains.</a:t>
+              <a:t>Raw, curated, refined zones accept any format, but without governance the lake becomes a swamp, and the central-team bottleneck remains.</a:t>
             </a:r>
             <a:endParaRPr lang="en-US" sz="1250" dirty="0"/>
           </a:p>
@@ -6075,7 +6075,7 @@
                 <a:ea typeface="Red Hat Text" pitchFamily="34" charset="-122"/>
                 <a:cs typeface="Red Hat Text" pitchFamily="34" charset="-120"/>
               </a:rPr>
-              <a:t>Traditionally two separate technology layers joined by pipelines — the mesh reorganizes the same distinction by domain instead.</a:t>
+              <a:t>Traditionally two separate technology layers joined by pipelines; the mesh reorganizes the same distinction by domain instead.</a:t>
             </a:r>
             <a:endParaRPr lang="en-US" sz="1250" dirty="0"/>
           </a:p>
@@ -6248,7 +6248,7 @@
                 <a:ea typeface="Overpass SemiBold" pitchFamily="34" charset="-122"/>
                 <a:cs typeface="Overpass SemiBold" pitchFamily="34" charset="-120"/>
               </a:rPr>
-              <a:t>The mesh — decentralized, domain-owned data products</a:t>
+              <a:t>The mesh: decentralized, domain-owned data products</a:t>
             </a:r>
             <a:endParaRPr lang="en-US" sz="3000" dirty="0"/>
           </a:p>
@@ -6311,7 +6311,7 @@
                 <a:ea typeface="Red Hat Text" pitchFamily="34" charset="-122"/>
                 <a:cs typeface="Red Hat Text" pitchFamily="34" charset="-120"/>
               </a:rPr>
-              <a:t>Each domain owns its data as a product, on a shared platform under federated governance — the organizational answer.</a:t>
+              <a:t>Each domain owns its data as a product, on a shared platform under federated governance: the organizational answer.</a:t>
             </a:r>
             <a:endParaRPr lang="en-US" sz="1250" dirty="0"/>
           </a:p>
@@ -6484,7 +6484,7 @@
                 <a:ea typeface="Overpass SemiBold" pitchFamily="34" charset="-122"/>
                 <a:cs typeface="Overpass SemiBold" pitchFamily="34" charset="-120"/>
               </a:rPr>
-              <a:t>The evolution — from pipelines to mesh</a:t>
+              <a:t>The evolution: from pipelines to mesh</a:t>
             </a:r>
             <a:endParaRPr lang="en-US" sz="3000" dirty="0"/>
           </a:p>

</xml_diff>

<commit_message>
fix: reconcile ch03 to current order-service code + rebuild decks em-dash-clean (#66)
- ch03: update the placeOrder/OrderEventProducer code blocks and the #C
  callout to the current CDI-event pattern. order-service fires a CDI
  Event<Order> inside the @Transactional method and OrderEventProducer
  observes it with @Observes(during = AFTER_SUCCESS), so the Kafka publish
  runs only after commit. Replaces the stale eventProducer.publish(...)
  .exceptionally(...) inline shown before. The naive before-cut and the
  dual-write/outbox point are unchanged.
- Decks: remove em-dashes from both deck sources (one verbatim test string
  kept), re-raster figures, and rebuild both .pptx so they use the renamed
  final-project figures instead of the stale capstone rasters.

Verified: ch03 0 em-dash / 0 ban-tier, jekyll build clean, both deck builders
pass node -c and regenerate their pptx.
</commit_message>
<xml_diff>
--- a/presentation/datamesh-101/Datamesh_101-r1.1.pptx
+++ b/presentation/datamesh-101/Datamesh_101-r1.1.pptx
@@ -607,7 +607,7 @@
           <a:p>
             <a:r>
               <a:rPr lang="en-US" dirty="0"/>
-              <a:t>Domain ownership: data is owned end to end by the domain team that produces it; no central team 'owns the warehouse.' Data as a product: a data product is held to the same bar as any software product: discoverable, addressable, trustworthy, self-describing. It is not a renamed table. Self-serve data platform: domain teams shouldn't each build their own event streaming, observability, or registry; the platform provides that as shared infrastructure. Federated computational governance: standards are enforced computationally, by the platform, automatically — not by review meetings. All four together are what make a mesh a mesh rather than just a lot of disconnected microservices each hoarding their own data.</a:t>
+              <a:t>Domain ownership: data is owned end to end by the domain team that produces it; no central team 'owns the warehouse.' Data as a product: a data product is held to the same bar as any software product: discoverable, addressable, trustworthy, self-describing. It is not a renamed table. Self-serve data platform: domain teams shouldn't each build their own event streaming, observability, or registry; the platform provides that as shared infrastructure. Federated computational governance: standards are enforced computationally, by the platform, automatically, not by review meetings. All four together are what make a mesh a mesh rather than just a lot of disconnected microservices each hoarding their own data.</a:t>
             </a:r>
             <a:endParaRPr lang="en-US" dirty="0"/>
           </a:p>
@@ -695,7 +695,7 @@
           <a:p>
             <a:r>
               <a:rPr lang="en-US" dirty="0"/>
-              <a:t>The analogy for anyone who has been through a monolith-to-microservices transition. Just as a monolithic application gets refactored into bounded contexts owned by domain teams (the microservices transition many engineers have already lived through), a monolithic data platform gets refactored into bounded data products owned by those same domain teams. The mesh is the network of those products plus the platform and standards that let them interoperate. The hard part was never drawing the boxes; it was deciding where one bounded context ends and the next begins, and then living with the contract at that boundary. Decomposing a data platform into data products is the identical exercise, one layer up — the boundary is now a versioned data contract instead of a REST endpoint.</a:t>
+              <a:t>The analogy for anyone who has been through a monolith-to-microservices transition. Just as a monolithic application gets refactored into bounded contexts owned by domain teams (the microservices transition many engineers have already lived through), a monolithic data platform gets refactored into bounded data products owned by those same domain teams. The mesh is the network of those products plus the platform and standards that let them interoperate. The hard part was never drawing the boxes; it was deciding where one bounded context ends and the next begins, and then living with the contract at that boundary. Decomposing a data platform into data products is the identical exercise, one layer up: the boundary is now a versioned data contract instead of a REST endpoint.</a:t>
             </a:r>
             <a:endParaRPr lang="en-US" dirty="0"/>
           </a:p>
@@ -783,7 +783,7 @@
           <a:p>
             <a:r>
               <a:rPr lang="en-US" dirty="0"/>
-              <a:t>Now let's bring this back to the room. Why build a data mesh on Quarkus and Kubernetes specifically? Because Quarkus gives a single, coherent developer experience across every protocol a domain service needs (REST, gRPC, GraphQL, Kafka) without ten disconnected quickstarts, and Kubernetes's primitives map onto the four principles unusually cleanly: namespaces for domain ownership, Deployments and CRDs for data as a product, operators for the self-serve platform, and mesh/admission policy for federated governance. This section is a fast teaser — the depth lives in the 201.</a:t>
+              <a:t>Now let's bring this back to the room. Why build a data mesh on Quarkus and Kubernetes specifically? Because Quarkus gives a single, coherent developer experience across every protocol a domain service needs (REST, gRPC, GraphQL, Kafka) without ten disconnected quickstarts, and Kubernetes's primitives map onto the four principles unusually cleanly: namespaces for domain ownership, Deployments and CRDs for data as a product, operators for the self-serve platform, and mesh/admission policy for federated governance. This section is a fast teaser; the depth lives in the 201.</a:t>
             </a:r>
             <a:endParaRPr lang="en-US" dirty="0"/>
           </a:p>
@@ -871,7 +871,7 @@
           <a:p>
             <a:r>
               <a:rPr lang="en-US" dirty="0"/>
-              <a:t>This reference architecture uses Quarkus for every domain service (order, inventory, payment, shipping, notification, review) and demonstrates twelve capabilities, among them Panache for persistence, gRPC for typed inter-domain calls, GraphQL for a federated gateway, Reactive Messaging for Kafka-backed events, and WebSockets.Next for live pushes, with reactive and imperative handlers sharing one Vert.x reactor. The tour also covers the JDK 25 AOT cache, native image, OIDC, JBang, and Panama FFM. With fast boot and a small memory footprint, Quarkus gives a domain team a way to stand up a well-behaved data product without first becoming distributed-systems experts, which is what makes it a credible vehicle for rolling a data mesh out across many enterprise teams. This is a teaser — the full capability tour, with a Spring Boot twin service for a side-by-side comparison, is the centerpiece of the 201.</a:t>
+              <a:t>This reference architecture uses Quarkus for every domain service (order, inventory, payment, shipping, notification, review) and demonstrates twelve capabilities, among them Panache for persistence, gRPC for typed inter-domain calls, GraphQL for a federated gateway, Reactive Messaging for Kafka-backed events, and WebSockets.Next for live pushes, with reactive and imperative handlers sharing one Vert.x reactor. The tour also covers the JDK 25 AOT cache, native image, OIDC, JBang, and Panama FFM. With fast boot and a small memory footprint, Quarkus gives a domain team a way to stand up a well-behaved data product without first becoming distributed-systems experts, which is what makes it a credible vehicle for rolling a data mesh out across many enterprise teams. This is a teaser; the full capability tour, with a Spring Boot twin service for a side-by-side comparison, is the centerpiece of the 201.</a:t>
             </a:r>
             <a:endParaRPr lang="en-US" dirty="0"/>
           </a:p>
@@ -959,7 +959,7 @@
           <a:p>
             <a:r>
               <a:rPr lang="en-US" dirty="0"/>
-              <a:t>Every event-driven system eventually has to answer one question: when multiple steps need to happen in sequence, who decides the sequence? This build runs three answers side by side over the same shipping/order domain. Kafka choreography: no one is in charge — order-service publishes order.placed and has never heard of payment-service or shipping-service; each service only knows 'when I see event X, I do Y and emit Z.' Camel orchestration: one route explicitly sequences every step, imperative code you read top to bottom. Quarkus Flow orchestration: the same two steps expressed declaratively, as a workflow document rather than hand-written control flow — the same shape, two different engines. For an enterprise mesh the advantage is that all three run on one Quarkus runtime, so a domain team picks the coordination style that fits each step without standing up a separate workflow server or routing through a shared ESB. The 201 covers this comparison in full, using the terms choreography and orchestration exactly.</a:t>
+              <a:t>Every event-driven system eventually has to answer one question: when multiple steps need to happen in sequence, who decides the sequence? This build runs three answers side by side over the same shipping/order domain. Kafka choreography: no one is in charge; order-service publishes order.placed and has never heard of payment-service or shipping-service; each service only knows 'when I see event X, I do Y and emit Z.' Camel orchestration: one route explicitly sequences every step, imperative code you read top to bottom. Quarkus Flow orchestration: the same two steps expressed declaratively, as a workflow document rather than hand-written control flow; the same shape, two different engines. For an enterprise mesh the advantage is that all three run on one Quarkus runtime, so a domain team picks the coordination style that fits each step without standing up a separate workflow server or routing through a shared ESB. The 201 covers this comparison in full, using the terms choreography and orchestration exactly.</a:t>
             </a:r>
             <a:endParaRPr lang="en-US" dirty="0"/>
           </a:p>
@@ -1311,7 +1311,7 @@
           <a:p>
             <a:r>
               <a:rPr lang="en-US" dirty="0"/>
-              <a:t>That's where to go next. The two codes carry the talk home: on the left, the reference architecture itself — the site, the runnable Quarkus domain services, the contracts and schema catalog, and the single-command minikube bootstrap that stands the whole mesh up on a laptop. On the right, the Workshops and Tutorials hub: every workshop, tutorial, and deck in the series in one place, including the 201 deep-dive. Scan whichever is useful; both are public on the Pattern Catalyst GitHub organization.</a:t>
+              <a:t>That's where to go next. The two codes carry the talk home: on the left, the reference architecture itself: the site, the runnable Quarkus domain services, the contracts and schema catalog, and the single-command minikube bootstrap that stands the whole mesh up on a laptop. On the right, the Workshops and Tutorials hub: every workshop, tutorial, and deck in the series in one place, including the 201 deep-dive. Scan whichever is useful; both are public on the Pattern Catalyst GitHub organization.</a:t>
             </a:r>
             <a:endParaRPr lang="en-US" dirty="0"/>
           </a:p>
@@ -1399,7 +1399,7 @@
           <a:p>
             <a:r>
               <a:rPr lang="en-US" dirty="0"/>
-              <a:t>Before we can appreciate what a data mesh is, we need to see what came before it. Every pattern in this section — pipelines, warehouses, lakes — solved a real problem for its era. None of them is wrong. The mesh does not replace all of them; it responds to a specific organizational scaling problem that none of them fully solves. We'll walk through each pattern quickly, then see how they led to the mesh.</a:t>
+              <a:t>Before we can appreciate what a data mesh is, we need to see what came before it. Every pattern in this section (pipelines, warehouses, lakes) solved a real problem for its era. None of them is wrong. The mesh does not replace all of them; it responds to a specific organizational scaling problem that none of them fully solves. We'll walk through each pattern quickly, then see how they led to the mesh.</a:t>
             </a:r>
             <a:endParaRPr lang="en-US" dirty="0"/>
           </a:p>
@@ -1487,7 +1487,7 @@
           <a:p>
             <a:r>
               <a:rPr lang="en-US" dirty="0"/>
-              <a:t>The oldest data architecture problem is movement: operational systems produce data, analytical systems consume it, and something has to get it from one to the other. A pipeline is that something — ETL or ELT, it doesn't matter which, both are linear, bespoke, point-to-point flows from a known source to a known destination. The limitation is pipeline sprawl: each new source or destination doesn't add one pipeline, it adds as many as there are things on the other side. Nobody owns the data flowing through a pipeline — it's plumbing, not a product. That's the seed of everything that follows.</a:t>
+              <a:t>The oldest data architecture problem is movement: operational systems produce data, analytical systems consume it, and something has to get it from one to the other. A pipeline is that something: ETL or ELT, it doesn't matter which, both are linear, bespoke, point-to-point flows from a known source to a known destination. The limitation is pipeline sprawl: each new source or destination doesn't add one pipeline, it adds as many as there are things on the other side. Nobody owns the data flowing through a pipeline; it's plumbing, not a product. That's the seed of everything that follows.</a:t>
             </a:r>
             <a:endParaRPr lang="en-US" dirty="0"/>
           </a:p>
@@ -1575,7 +1575,7 @@
           <a:p>
             <a:r>
               <a:rPr lang="en-US" dirty="0"/>
-              <a:t>The warehouse solved the truth problem pipeline sprawl created: instead of every consumer building its own understanding from raw pipeline output, everyone queries the same curated, schema-on-write model. The limitation is organizational, not technical — a central data team owns all the data but understands none of the domains it came from. Every schema change, every new source funnels through that one team, and as the organization grows, the queue becomes the bottleneck. This is the bottleneck a data mesh exists to remove — not by building a better warehouse, but by changing who owns the data.</a:t>
+              <a:t>The warehouse solved the truth problem pipeline sprawl created: instead of every consumer building its own understanding from raw pipeline output, everyone queries the same curated, schema-on-write model. The limitation is organizational, not technical: a central data team owns all the data but understands none of the domains it came from. Every schema change, every new source funnels through that one team, and as the organization grows, the queue becomes the bottleneck. This is the bottleneck a data mesh exists to remove, not by building a better warehouse, but by changing who owns the data.</a:t>
             </a:r>
             <a:endParaRPr lang="en-US" dirty="0"/>
           </a:p>
@@ -1663,7 +1663,7 @@
           <a:p>
             <a:r>
               <a:rPr lang="en-US" dirty="0"/>
-              <a:t>The lake solved the warehouse's format rigidity — it accepts structured, semi-structured, unstructured, and streaming data, and defers schema decisions to the point of consumption, schema-on-read instead of schema-on-write. Zone-based organization (raw, curated, refined) is how well-run lakes stay usable. But without active curation, the lake becomes a data swamp: undocumented, stale, duplicated datasets nobody trusts. And notice what didn't change — a central team still owns the bucket. The lake fixed the format problem, not the organizational one.</a:t>
+              <a:t>The lake solved the warehouse's format rigidity: it accepts structured, semi-structured, unstructured, and streaming data, and defers schema decisions to the point of consumption, schema-on-read instead of schema-on-write. Zone-based organization (raw, curated, refined) is how well-run lakes stay usable. But without active curation, the lake becomes a data swamp: undocumented, stale, duplicated datasets nobody trusts. And notice what didn't change: a central team still owns the bucket. The lake fixed the format problem, not the organizational one.</a:t>
             </a:r>
             <a:endParaRPr lang="en-US" dirty="0"/>
           </a:p>
@@ -1751,7 +1751,7 @@
           <a:p>
             <a:r>
               <a:rPr lang="en-US" dirty="0"/>
-              <a:t>One more distinction underlies everything before we get to the mesh itself. Operational data is the current-state data behind a domain's running services — the rows a microservice reads and writes to do its job. Analytical data is the historical, aggregated view used for decisions and models. Traditionally these live in separate worlds joined by a tangle of ETL on a delay — all operational data here, all analytical data there, pipelines between. A data mesh doesn't erase that distinction, but reorganizes it by domain rather than by technology layer: each domain owns both its operational systems and the analytical products derived from them. That is the seam the mesh closes.</a:t>
+              <a:t>One more distinction underlies everything before we get to the mesh itself. Operational data is the current-state data behind a domain's running services: the rows a microservice reads and writes to do its job. Analytical data is the historical, aggregated view used for decisions and models. Traditionally these live in separate worlds joined by a tangle of ETL on a delay: all operational data here, all analytical data there, pipelines between. A data mesh doesn't erase that distinction, but reorganizes it by domain rather than by technology layer: each domain owns both its operational systems and the analytical products derived from them. That is the seam the mesh closes.</a:t>
             </a:r>
             <a:endParaRPr lang="en-US" dirty="0"/>
           </a:p>
@@ -1839,7 +1839,7 @@
           <a:p>
             <a:r>
               <a:rPr lang="en-US" dirty="0"/>
-              <a:t>This is the pivot. All three prior patterns (pipelines, warehouses, lakes) centralize data and hand ownership to a single team; the technology improves generation by generation but the organizational shape stays the same. The mesh changes the axis: instead of building a better center, decentralize ownership to the domains that produce the data. Each domain owns its data as a product that is discoverable, addressable, trustworthy, and self-describing, and talks to other domains directly. A shared self-serve platform provides the infrastructure underneath, and federated computational governance keeps the independently-owned products interoperable. Notice there's no 'central data team' card on this diagram at all — that's the point.</a:t>
+              <a:t>This is the pivot. All three prior patterns (pipelines, warehouses, lakes) centralize data and hand ownership to a single team; the technology improves generation by generation but the organizational shape stays the same. The mesh changes the axis: instead of building a better center, decentralize ownership to the domains that produce the data. Each domain owns its data as a product that is discoverable, addressable, trustworthy, and self-describing, and talks to other domains directly. A shared self-serve platform provides the infrastructure underneath, and federated computational governance keeps the independently-owned products interoperable. Notice there's no 'central data team' card on this diagram at all; that's the point.</a:t>
             </a:r>
             <a:endParaRPr lang="en-US" dirty="0"/>
           </a:p>
@@ -2015,7 +2015,7 @@
           <a:p>
             <a:r>
               <a:rPr lang="en-US" dirty="0"/>
-              <a:t>With the landscape in place, let's define data mesh. Zhamak Dehghani coined the term in 2019 and formalized it in her 2022 O'Reilly book. It rests on four interlocking principles that depend on each other — implement one without the others and you get a distributed mess, not a mesh. We'll look at all four together, then at the analogy that makes them concrete for anyone who has lived through a monolith-to-microservices transition: the same decomposition, applied to data ownership instead of application code.</a:t>
+              <a:t>With the landscape in place, let's define data mesh. Zhamak Dehghani coined the term in 2019 and formalized it in her 2022 O'Reilly book. It rests on four interlocking principles that depend on each other; implement one without the others and you get a distributed mess, not a mesh. We'll look at all four together, then at the analogy that makes them concrete for anyone who has lived through a monolith-to-microservices transition: the same decomposition, applied to data ownership instead of application code.</a:t>
             </a:r>
             <a:endParaRPr lang="en-US" dirty="0"/>
           </a:p>
@@ -2525,7 +2525,7 @@
                 <a:ea typeface="Red Hat Text" pitchFamily="34" charset="-122"/>
                 <a:cs typeface="Red Hat Text" pitchFamily="34" charset="-120"/>
               </a:rPr>
-              <a:t>From data-mesh principles to a running platform on Quarkus and Kubernetes — no Quarkus experience assumed</a:t>
+              <a:t>From data-mesh principles to a running platform on Quarkus and Kubernetes (no Quarkus experience assumed)</a:t>
             </a:r>
             <a:endParaRPr lang="en-US" sz="1700" dirty="0"/>
           </a:p>
@@ -2761,7 +2761,7 @@
                 <a:ea typeface="Red Hat Text" pitchFamily="34" charset="-122"/>
                 <a:cs typeface="Red Hat Text" pitchFamily="34" charset="-120"/>
               </a:rPr>
-              <a:t>The four principles depend on each other — implement one without the others and you get a distributed mess, not a mesh.</a:t>
+              <a:t>The four principles depend on each other; implement one without the others and you get a distributed mess, not a mesh.</a:t>
             </a:r>
             <a:endParaRPr lang="en-US" sz="1250" dirty="0"/>
           </a:p>
@@ -3425,7 +3425,7 @@
                 <a:ea typeface="Red Hat Text" pitchFamily="34" charset="-122"/>
                 <a:cs typeface="Red Hat Text" pitchFamily="34" charset="-120"/>
               </a:rPr>
-              <a:t>REST, gRPC, GraphQL, Kafka, reactive and imperative in one JVM, fast boot, low memory — one coherent toolchain across every data-product surface.</a:t>
+              <a:t>REST, gRPC, GraphQL, Kafka, reactive and imperative in one JVM, fast boot, low memory: one coherent toolchain across every data-product surface.</a:t>
             </a:r>
             <a:endParaRPr lang="en-US" sz="1250" dirty="0"/>
           </a:p>
@@ -3598,7 +3598,7 @@
                 <a:ea typeface="Overpass SemiBold" pitchFamily="34" charset="-122"/>
                 <a:cs typeface="Overpass SemiBold" pitchFamily="34" charset="-120"/>
               </a:rPr>
-              <a:t>Choreography vs. orchestration — one domain, three coordination engines</a:t>
+              <a:t>Choreography vs. orchestration: one domain, three coordination engines</a:t>
             </a:r>
             <a:endParaRPr lang="en-US" sz="3000" dirty="0"/>
           </a:p>
@@ -3842,7 +3842,7 @@
       </p:sp>
       <p:pic>
         <p:nvPicPr>
-          <p:cNvPr id="4" name="Image 0" descr="dpng/02-capstone-data-mesh.png">    </p:cNvPr>
+          <p:cNvPr id="4" name="Image 0" descr="dpng/02-final-project-data-mesh.png">    </p:cNvPr>
           <p:cNvPicPr>
             <a:picLocks noChangeAspect="1"/>
           </p:cNvPicPr>
@@ -4116,7 +4116,7 @@
                 <a:ea typeface="Red Hat Text" pitchFamily="34" charset="-122"/>
                 <a:cs typeface="Red Hat Text" pitchFamily="34" charset="-120"/>
               </a:rPr>
-              <a:t>The choice depends on scale, data landscape, and where the bottleneck sits — not on which pattern is newest. A data mesh is not always the answer.</a:t>
+              <a:t>The choice depends on scale, data landscape, and where the bottleneck sits, not on which pattern is newest. A data mesh is not always the answer.</a:t>
             </a:r>
             <a:endParaRPr lang="en-US" sz="1600" dirty="0"/>
           </a:p>
@@ -4292,7 +4292,7 @@
                 <a:ea typeface="Red Hat Text" pitchFamily="34" charset="-122"/>
                 <a:cs typeface="Red Hat Text" pitchFamily="34" charset="-120"/>
               </a:rPr>
-              <a:t>Many domains, many consumers, and a central team has become the constraint — and the organization has the maturity to operate federated ownership.</a:t>
+              <a:t>Many domains, many consumers, and a central team has become the constraint, and the organization has the maturity to operate federated ownership.</a:t>
             </a:r>
             <a:endParaRPr lang="en-US" sz="1600" dirty="0"/>
           </a:p>
@@ -4963,7 +4963,7 @@
                 <a:ea typeface="Red Hat Text" pitchFamily="34" charset="-122"/>
                 <a:cs typeface="Red Hat Text" pitchFamily="34" charset="-120"/>
               </a:rPr>
-              <a:t>The whole series — every workshop, tutorial, and deck in one place</a:t>
+              <a:t>The whole series: every workshop, tutorial, and deck in one place</a:t>
             </a:r>
             <a:endParaRPr lang="en-US" sz="1300" dirty="0"/>
           </a:p>
@@ -5170,7 +5170,7 @@
                 <a:ea typeface="Red Hat Text" pitchFamily="34" charset="-122"/>
                 <a:cs typeface="Red Hat Text" pitchFamily="34" charset="-120"/>
               </a:rPr>
-              <a:t>Four data architectures — what each pattern solves and the limitation it leaves behind.</a:t>
+              <a:t>Four data architectures: what each pattern solves and the limitation it leaves behind.</a:t>
             </a:r>
             <a:endParaRPr lang="en-US" sz="1600" dirty="0"/>
           </a:p>
@@ -5304,7 +5304,7 @@
                 <a:ea typeface="Overpass SemiBold" pitchFamily="34" charset="-122"/>
                 <a:cs typeface="Overpass SemiBold" pitchFamily="34" charset="-120"/>
               </a:rPr>
-              <a:t>Data pipelines — the plumbing</a:t>
+              <a:t>Data pipelines: the plumbing</a:t>
             </a:r>
             <a:endParaRPr lang="en-US" sz="3000" dirty="0"/>
           </a:p>
@@ -5540,7 +5540,7 @@
                 <a:ea typeface="Overpass SemiBold" pitchFamily="34" charset="-122"/>
                 <a:cs typeface="Overpass SemiBold" pitchFamily="34" charset="-120"/>
               </a:rPr>
-              <a:t>Data warehouses — many sources, one team, one store</a:t>
+              <a:t>Data warehouses: many sources, one team, one store</a:t>
             </a:r>
             <a:endParaRPr lang="en-US" sz="3000" dirty="0"/>
           </a:p>
@@ -5603,7 +5603,7 @@
                 <a:ea typeface="Red Hat Text" pitchFamily="34" charset="-122"/>
                 <a:cs typeface="Red Hat Text" pitchFamily="34" charset="-120"/>
               </a:rPr>
-              <a:t>A centralized, governed analytical store — and the central team that owns it becomes the single point of contention.</a:t>
+              <a:t>A centralized, governed analytical store, and the central team that owns it becomes the single point of contention.</a:t>
             </a:r>
             <a:endParaRPr lang="en-US" sz="1250" dirty="0"/>
           </a:p>
@@ -5776,7 +5776,7 @@
                 <a:ea typeface="Overpass SemiBold" pitchFamily="34" charset="-122"/>
                 <a:cs typeface="Overpass SemiBold" pitchFamily="34" charset="-120"/>
               </a:rPr>
-              <a:t>Data lakes — flexible on the way in, swamp risk on the way out</a:t>
+              <a:t>Data lakes: flexible on the way in, swamp risk on the way out</a:t>
             </a:r>
             <a:endParaRPr lang="en-US" sz="3000" dirty="0"/>
           </a:p>
@@ -5839,7 +5839,7 @@
                 <a:ea typeface="Red Hat Text" pitchFamily="34" charset="-122"/>
                 <a:cs typeface="Red Hat Text" pitchFamily="34" charset="-120"/>
               </a:rPr>
-              <a:t>Raw, curated, refined zones accept any format — but without governance the lake becomes a swamp, and the central-team bottleneck remains.</a:t>
+              <a:t>Raw, curated, refined zones accept any format, but without governance the lake becomes a swamp, and the central-team bottleneck remains.</a:t>
             </a:r>
             <a:endParaRPr lang="en-US" sz="1250" dirty="0"/>
           </a:p>
@@ -6075,7 +6075,7 @@
                 <a:ea typeface="Red Hat Text" pitchFamily="34" charset="-122"/>
                 <a:cs typeface="Red Hat Text" pitchFamily="34" charset="-120"/>
               </a:rPr>
-              <a:t>Traditionally two separate technology layers joined by pipelines — the mesh reorganizes the same distinction by domain instead.</a:t>
+              <a:t>Traditionally two separate technology layers joined by pipelines; the mesh reorganizes the same distinction by domain instead.</a:t>
             </a:r>
             <a:endParaRPr lang="en-US" sz="1250" dirty="0"/>
           </a:p>
@@ -6248,7 +6248,7 @@
                 <a:ea typeface="Overpass SemiBold" pitchFamily="34" charset="-122"/>
                 <a:cs typeface="Overpass SemiBold" pitchFamily="34" charset="-120"/>
               </a:rPr>
-              <a:t>The mesh — decentralized, domain-owned data products</a:t>
+              <a:t>The mesh: decentralized, domain-owned data products</a:t>
             </a:r>
             <a:endParaRPr lang="en-US" sz="3000" dirty="0"/>
           </a:p>
@@ -6311,7 +6311,7 @@
                 <a:ea typeface="Red Hat Text" pitchFamily="34" charset="-122"/>
                 <a:cs typeface="Red Hat Text" pitchFamily="34" charset="-120"/>
               </a:rPr>
-              <a:t>Each domain owns its data as a product, on a shared platform under federated governance — the organizational answer.</a:t>
+              <a:t>Each domain owns its data as a product, on a shared platform under federated governance: the organizational answer.</a:t>
             </a:r>
             <a:endParaRPr lang="en-US" sz="1250" dirty="0"/>
           </a:p>
@@ -6484,7 +6484,7 @@
                 <a:ea typeface="Overpass SemiBold" pitchFamily="34" charset="-122"/>
                 <a:cs typeface="Overpass SemiBold" pitchFamily="34" charset="-120"/>
               </a:rPr>
-              <a:t>The evolution — from pipelines to mesh</a:t>
+              <a:t>The evolution: from pipelines to mesh</a:t>
             </a:r>
             <a:endParaRPr lang="en-US" sz="3000" dirty="0"/>
           </a:p>

</xml_diff>